<commit_message>
docs(added page 7 in ppt with lexical feature definitions)
</commit_message>
<xml_diff>
--- a/Part2.pptx
+++ b/Part2.pptx
@@ -5,7 +5,7 @@
     <p:sldMasterId id="2147483648" r:id="rId1"/>
   </p:sldMasterIdLst>
   <p:notesMasterIdLst>
-    <p:notesMasterId r:id="rId19"/>
+    <p:notesMasterId r:id="rId20"/>
   </p:notesMasterIdLst>
   <p:sldIdLst>
     <p:sldId id="256" r:id="rId2"/>
@@ -14,17 +14,18 @@
     <p:sldId id="267" r:id="rId5"/>
     <p:sldId id="259" r:id="rId6"/>
     <p:sldId id="260" r:id="rId7"/>
-    <p:sldId id="268" r:id="rId8"/>
-    <p:sldId id="269" r:id="rId9"/>
-    <p:sldId id="270" r:id="rId10"/>
-    <p:sldId id="261" r:id="rId11"/>
-    <p:sldId id="271" r:id="rId12"/>
-    <p:sldId id="262" r:id="rId13"/>
-    <p:sldId id="263" r:id="rId14"/>
-    <p:sldId id="272" r:id="rId15"/>
-    <p:sldId id="264" r:id="rId16"/>
-    <p:sldId id="265" r:id="rId17"/>
-    <p:sldId id="266" r:id="rId18"/>
+    <p:sldId id="274" r:id="rId8"/>
+    <p:sldId id="268" r:id="rId9"/>
+    <p:sldId id="269" r:id="rId10"/>
+    <p:sldId id="270" r:id="rId11"/>
+    <p:sldId id="261" r:id="rId12"/>
+    <p:sldId id="271" r:id="rId13"/>
+    <p:sldId id="262" r:id="rId14"/>
+    <p:sldId id="263" r:id="rId15"/>
+    <p:sldId id="272" r:id="rId16"/>
+    <p:sldId id="264" r:id="rId17"/>
+    <p:sldId id="265" r:id="rId18"/>
+    <p:sldId id="266" r:id="rId19"/>
   </p:sldIdLst>
   <p:sldSz cx="9144000" cy="5143500" type="screen16x9"/>
   <p:notesSz cx="5143500" cy="9144000"/>
@@ -405,7 +406,7 @@
           <a:p>
             <a:fld id="{F7021451-1387-4CA6-816F-3879F97B5CBC}" type="slidenum">
               <a:rPr lang="en-US"/>
-              <a:t>16</a:t>
+              <a:t>17</a:t>
             </a:fld>
             <a:endParaRPr lang="en-US"/>
           </a:p>
@@ -492,7 +493,7 @@
           <a:p>
             <a:fld id="{F7021451-1387-4CA6-816F-3879F97B5CBC}" type="slidenum">
               <a:rPr lang="en-US"/>
-              <a:t>17</a:t>
+              <a:t>18</a:t>
             </a:fld>
             <a:endParaRPr lang="en-US"/>
           </a:p>
@@ -927,7 +928,7 @@
           <a:p>
             <a:fld id="{F7021451-1387-4CA6-816F-3879F97B5CBC}" type="slidenum">
               <a:rPr lang="en-US"/>
-              <a:t>10</a:t>
+              <a:t>11</a:t>
             </a:fld>
             <a:endParaRPr lang="en-US"/>
           </a:p>
@@ -1014,7 +1015,7 @@
           <a:p>
             <a:fld id="{F7021451-1387-4CA6-816F-3879F97B5CBC}" type="slidenum">
               <a:rPr lang="en-US"/>
-              <a:t>12</a:t>
+              <a:t>13</a:t>
             </a:fld>
             <a:endParaRPr lang="en-US"/>
           </a:p>
@@ -1101,7 +1102,7 @@
           <a:p>
             <a:fld id="{F7021451-1387-4CA6-816F-3879F97B5CBC}" type="slidenum">
               <a:rPr lang="en-US"/>
-              <a:t>13</a:t>
+              <a:t>14</a:t>
             </a:fld>
             <a:endParaRPr lang="en-US"/>
           </a:p>
@@ -1188,7 +1189,7 @@
           <a:p>
             <a:fld id="{F7021451-1387-4CA6-816F-3879F97B5CBC}" type="slidenum">
               <a:rPr lang="en-US"/>
-              <a:t>15</a:t>
+              <a:t>16</a:t>
             </a:fld>
             <a:endParaRPr lang="en-US"/>
           </a:p>
@@ -2108,6 +2109,608 @@
 
 <file path=ppt/slides/slide10.xml><?xml version="1.0" encoding="utf-8"?>
 <p:sld xmlns:a="http://schemas.openxmlformats.org/drawingml/2006/main" xmlns:r="http://schemas.openxmlformats.org/officeDocument/2006/relationships" xmlns:p="http://schemas.openxmlformats.org/presentationml/2006/main">
+  <p:cSld name="Slide 15">
+    <p:bg>
+      <p:bgPr>
+        <a:solidFill>
+          <a:srgbClr val="F4F7FA"/>
+        </a:solidFill>
+        <a:effectLst/>
+      </p:bgPr>
+    </p:bg>
+    <p:spTree>
+      <p:nvGrpSpPr>
+        <p:cNvPr id="1" name=""/>
+        <p:cNvGrpSpPr/>
+        <p:nvPr/>
+      </p:nvGrpSpPr>
+      <p:grpSpPr>
+        <a:xfrm>
+          <a:off x="0" y="0"/>
+          <a:ext cx="0" cy="0"/>
+          <a:chOff x="0" y="0"/>
+          <a:chExt cx="0" cy="0"/>
+        </a:xfrm>
+      </p:grpSpPr>
+      <p:sp>
+        <p:nvSpPr>
+          <p:cNvPr id="2" name="Hdr"/>
+          <p:cNvSpPr/>
+          <p:nvPr/>
+        </p:nvSpPr>
+        <p:spPr>
+          <a:xfrm>
+            <a:off x="0" y="0"/>
+            <a:ext cx="9144000" cy="658368"/>
+          </a:xfrm>
+          <a:prstGeom prst="rect">
+            <a:avLst/>
+          </a:prstGeom>
+          <a:solidFill>
+            <a:srgbClr val="0D1B2A"/>
+          </a:solidFill>
+          <a:ln w="12700">
+            <a:solidFill>
+              <a:srgbClr val="0D1B2A"/>
+            </a:solidFill>
+            <a:prstDash val="solid"/>
+          </a:ln>
+        </p:spPr>
+        <p:txBody>
+          <a:bodyPr/>
+          <a:lstStyle/>
+          <a:p>
+            <a:endParaRPr lang="en-US"/>
+          </a:p>
+        </p:txBody>
+      </p:sp>
+      <p:sp>
+        <p:nvSpPr>
+          <p:cNvPr id="3" name="HdrTxt"/>
+          <p:cNvSpPr/>
+          <p:nvPr/>
+        </p:nvSpPr>
+        <p:spPr>
+          <a:xfrm>
+            <a:off x="384048" y="0"/>
+            <a:ext cx="8412480" cy="658368"/>
+          </a:xfrm>
+          <a:prstGeom prst="rect">
+            <a:avLst/>
+          </a:prstGeom>
+          <a:noFill/>
+          <a:ln/>
+        </p:spPr>
+        <p:txBody>
+          <a:bodyPr wrap="square" lIns="0" tIns="0" rIns="0" bIns="0" rtlCol="0" anchor="ctr"/>
+          <a:lstStyle/>
+          <a:p>
+            <a:pPr marL="0" indent="0">
+              <a:buNone/>
+            </a:pPr>
+            <a:r>
+              <a:rPr lang="en-US" sz="2000" b="1" dirty="0">
+                <a:solidFill>
+                  <a:srgbClr val="FFFFFF"/>
+                </a:solidFill>
+                <a:latin typeface="Calibri" pitchFamily="34" charset="0"/>
+              </a:rPr>
+              <a:t>Model: Logistic Regression</a:t>
+            </a:r>
+          </a:p>
+        </p:txBody>
+      </p:sp>
+      <p:sp>
+        <p:nvSpPr>
+          <p:cNvPr id="4" name="Ftr"/>
+          <p:cNvSpPr/>
+          <p:nvPr/>
+        </p:nvSpPr>
+        <p:spPr>
+          <a:xfrm>
+            <a:off x="0" y="4892040"/>
+            <a:ext cx="9144000" cy="251460"/>
+          </a:xfrm>
+          <a:prstGeom prst="rect">
+            <a:avLst/>
+          </a:prstGeom>
+          <a:solidFill>
+            <a:srgbClr val="1B2A41"/>
+          </a:solidFill>
+          <a:ln w="12700">
+            <a:solidFill>
+              <a:srgbClr val="1B2A41"/>
+            </a:solidFill>
+            <a:prstDash val="solid"/>
+          </a:ln>
+        </p:spPr>
+        <p:txBody>
+          <a:bodyPr/>
+          <a:lstStyle/>
+          <a:p>
+            <a:endParaRPr lang="en-US"/>
+          </a:p>
+        </p:txBody>
+      </p:sp>
+      <p:sp>
+        <p:nvSpPr>
+          <p:cNvPr id="5" name="FtrTxt"/>
+          <p:cNvSpPr/>
+          <p:nvPr/>
+        </p:nvSpPr>
+        <p:spPr>
+          <a:xfrm>
+            <a:off x="274320" y="4892040"/>
+            <a:ext cx="8595360" cy="251460"/>
+          </a:xfrm>
+          <a:prstGeom prst="rect">
+            <a:avLst/>
+          </a:prstGeom>
+          <a:noFill/>
+          <a:ln/>
+        </p:spPr>
+        <p:txBody>
+          <a:bodyPr wrap="square" lIns="0" tIns="0" rIns="0" bIns="0" rtlCol="0" anchor="ctr"/>
+          <a:lstStyle/>
+          <a:p>
+            <a:pPr marL="0" indent="0">
+              <a:buNone/>
+            </a:pPr>
+            <a:r>
+              <a:rPr lang="en-US" sz="800" dirty="0">
+                <a:solidFill>
+                  <a:srgbClr val="CADCFC"/>
+                </a:solidFill>
+                <a:latin typeface="Calibri" pitchFamily="34" charset="0"/>
+              </a:rPr>
+              <a:t>Malicious URL Detection  ·  Lexical Features Only  |  Model Concepts</a:t>
+            </a:r>
+          </a:p>
+        </p:txBody>
+      </p:sp>
+      <p:sp>
+        <p:nvSpPr>
+          <p:cNvPr id="6" name="LH"/>
+          <p:cNvSpPr/>
+          <p:nvPr/>
+        </p:nvSpPr>
+        <p:spPr>
+          <a:xfrm>
+            <a:off x="320040" y="750000"/>
+            <a:ext cx="4114800" cy="292608"/>
+          </a:xfrm>
+          <a:prstGeom prst="rect">
+            <a:avLst/>
+          </a:prstGeom>
+          <a:noFill/>
+          <a:ln/>
+        </p:spPr>
+        <p:txBody>
+          <a:bodyPr wrap="square" lIns="0" tIns="0" rIns="0" bIns="0" rtlCol="0" anchor="ctr"/>
+          <a:lstStyle/>
+          <a:p>
+            <a:pPr marL="0" indent="0">
+              <a:buNone/>
+            </a:pPr>
+            <a:r>
+              <a:rPr lang="en-US" sz="1300" b="1" dirty="0">
+                <a:solidFill>
+                  <a:srgbClr val="0D1B2A"/>
+                </a:solidFill>
+                <a:latin typeface="Calibri" pitchFamily="34" charset="0"/>
+              </a:rPr>
+              <a:t>How Logistic Regression Works</a:t>
+            </a:r>
+          </a:p>
+        </p:txBody>
+      </p:sp>
+      <p:sp>
+        <p:nvSpPr>
+          <p:cNvPr id="7" name="LB"/>
+          <p:cNvSpPr/>
+          <p:nvPr/>
+        </p:nvSpPr>
+        <p:spPr>
+          <a:xfrm>
+            <a:off x="320040" y="1080000"/>
+            <a:ext cx="4114800" cy="1480000"/>
+          </a:xfrm>
+          <a:prstGeom prst="rect">
+            <a:avLst/>
+          </a:prstGeom>
+          <a:noFill/>
+          <a:ln/>
+        </p:spPr>
+        <p:txBody>
+          <a:bodyPr wrap="square" lIns="0" tIns="0" rIns="0" bIns="0" rtlCol="0" anchor="t"/>
+          <a:lstStyle/>
+          <a:p>
+            <a:pPr marL="342900" indent="-342900">
+              <a:buSzPct val="100000"/>
+              <a:buChar char="•"/>
+            </a:pPr>
+            <a:r>
+              <a:rPr lang="en-US" sz="1050" dirty="0">
+                <a:solidFill>
+                  <a:srgbClr val="334155"/>
+                </a:solidFill>
+                <a:latin typeface="Calibri" pitchFamily="34" charset="0"/>
+              </a:rPr>
+              <a:t>Fits a weighted formula to the features and outputs a </a:t>
+            </a:r>
+            <a:r>
+              <a:rPr lang="en-US" sz="1050" b="1" dirty="0">
+                <a:solidFill>
+                  <a:srgbClr val="334155"/>
+                </a:solidFill>
+                <a:latin typeface="Calibri" pitchFamily="34" charset="0"/>
+              </a:rPr>
+              <a:t>probability of each class</a:t>
+            </a:r>
+          </a:p>
+          <a:p>
+            <a:pPr marL="342900" indent="-342900">
+              <a:buSzPct val="100000"/>
+              <a:buChar char="•"/>
+            </a:pPr>
+            <a:r>
+              <a:rPr lang="en-US" sz="1050" dirty="0">
+                <a:solidFill>
+                  <a:srgbClr val="334155"/>
+                </a:solidFill>
+                <a:latin typeface="Calibri" pitchFamily="34" charset="0"/>
+              </a:rPr>
+              <a:t>Each feature gets a </a:t>
+            </a:r>
+            <a:r>
+              <a:rPr lang="en-US" sz="1050" b="1" dirty="0">
+                <a:solidFill>
+                  <a:srgbClr val="334155"/>
+                </a:solidFill>
+                <a:latin typeface="Calibri" pitchFamily="34" charset="0"/>
+              </a:rPr>
+              <a:t>coefficient</a:t>
+            </a:r>
+            <a:r>
+              <a:rPr lang="en-US" sz="1050" dirty="0">
+                <a:solidFill>
+                  <a:srgbClr val="334155"/>
+                </a:solidFill>
+                <a:latin typeface="Calibri" pitchFamily="34" charset="0"/>
+              </a:rPr>
+              <a:t> — a positive value pushes toward malicious, negative toward benign</a:t>
+            </a:r>
+          </a:p>
+          <a:p>
+            <a:pPr marL="342900" indent="-342900">
+              <a:buSzPct val="100000"/>
+              <a:buChar char="•"/>
+            </a:pPr>
+            <a:r>
+              <a:rPr lang="en-US" sz="1050" dirty="0">
+                <a:solidFill>
+                  <a:srgbClr val="334155"/>
+                </a:solidFill>
+                <a:latin typeface="Calibri" pitchFamily="34" charset="0"/>
+              </a:rPr>
+              <a:t>Interpretable: you can read the coefficients to understand which URL features matter most</a:t>
+            </a:r>
+          </a:p>
+        </p:txBody>
+      </p:sp>
+      <p:sp>
+        <p:nvSpPr>
+          <p:cNvPr id="8" name="LSettings"/>
+          <p:cNvSpPr/>
+          <p:nvPr/>
+        </p:nvSpPr>
+        <p:spPr>
+          <a:xfrm>
+            <a:off x="320040" y="2680000"/>
+            <a:ext cx="4114800" cy="1080000"/>
+          </a:xfrm>
+          <a:prstGeom prst="rect">
+            <a:avLst/>
+          </a:prstGeom>
+          <a:solidFill>
+            <a:srgbClr val="E8F4F8"/>
+          </a:solidFill>
+          <a:ln w="9525">
+            <a:solidFill>
+              <a:srgbClr val="028090"/>
+            </a:solidFill>
+            <a:prstDash val="solid"/>
+          </a:ln>
+          <a:effectLst>
+            <a:outerShdw blurRad="101600" dist="38100" dir="8100000" algn="bl" rotWithShape="0">
+              <a:srgbClr val="000000">
+                <a:alpha val="12000"/>
+              </a:srgbClr>
+            </a:outerShdw>
+          </a:effectLst>
+        </p:spPr>
+        <p:txBody>
+          <a:bodyPr wrap="square" lIns="91440" tIns="91440" rIns="91440" bIns="91440" rtlCol="0" anchor="t"/>
+          <a:lstStyle/>
+          <a:p>
+            <a:pPr marL="0" indent="0">
+              <a:buNone/>
+            </a:pPr>
+            <a:r>
+              <a:rPr lang="en-US" sz="1100" b="1" dirty="0">
+                <a:solidFill>
+                  <a:srgbClr val="028090"/>
+                </a:solidFill>
+                <a:latin typeface="Calibri" pitchFamily="34" charset="0"/>
+              </a:rPr>
+              <a:t>Settings used: C=10, class_weight=balanced</a:t>
+            </a:r>
+          </a:p>
+          <a:p>
+            <a:pPr marL="342900" indent="-342900">
+              <a:buSzPct val="100000"/>
+              <a:buChar char="•"/>
+            </a:pPr>
+            <a:r>
+              <a:rPr lang="en-US" sz="1000" dirty="0">
+                <a:solidFill>
+                  <a:srgbClr val="334155"/>
+                </a:solidFill>
+                <a:latin typeface="Calibri" pitchFamily="34" charset="0"/>
+              </a:rPr>
+              <a:t>C=10: weak regularisation, allows the model to fit the data closely</a:t>
+            </a:r>
+          </a:p>
+          <a:p>
+            <a:pPr marL="342900" indent="-342900">
+              <a:buSzPct val="100000"/>
+              <a:buChar char="•"/>
+            </a:pPr>
+            <a:r>
+              <a:rPr lang="en-US" sz="1000" dirty="0">
+                <a:solidFill>
+                  <a:srgbClr val="334155"/>
+                </a:solidFill>
+                <a:latin typeface="Calibri" pitchFamily="34" charset="0"/>
+              </a:rPr>
+              <a:t>balanced weights: minority classes (malware, phishing) are up-weighted so the model does not ignore them</a:t>
+            </a:r>
+          </a:p>
+        </p:txBody>
+      </p:sp>
+      <p:sp>
+        <p:nvSpPr>
+          <p:cNvPr id="9" name="Div"/>
+          <p:cNvSpPr/>
+          <p:nvPr/>
+        </p:nvSpPr>
+        <p:spPr>
+          <a:xfrm>
+            <a:off x="4572000" y="720000"/>
+            <a:ext cx="27432" cy="4072000"/>
+          </a:xfrm>
+          <a:prstGeom prst="rect">
+            <a:avLst/>
+          </a:prstGeom>
+          <a:solidFill>
+            <a:srgbClr val="CADCFC"/>
+          </a:solidFill>
+          <a:ln w="0">
+            <a:noFill/>
+          </a:ln>
+        </p:spPr>
+        <p:txBody>
+          <a:bodyPr/>
+          <a:lstStyle/>
+          <a:p>
+            <a:endParaRPr lang="en-US"/>
+          </a:p>
+        </p:txBody>
+      </p:sp>
+      <p:sp>
+        <p:nvSpPr>
+          <p:cNvPr id="10" name="RH"/>
+          <p:cNvSpPr/>
+          <p:nvPr/>
+        </p:nvSpPr>
+        <p:spPr>
+          <a:xfrm>
+            <a:off x="4709160" y="750000"/>
+            <a:ext cx="4160880" cy="292608"/>
+          </a:xfrm>
+          <a:prstGeom prst="rect">
+            <a:avLst/>
+          </a:prstGeom>
+          <a:noFill/>
+          <a:ln/>
+        </p:spPr>
+        <p:txBody>
+          <a:bodyPr wrap="square" lIns="0" tIns="0" rIns="0" bIns="0" rtlCol="0" anchor="ctr"/>
+          <a:lstStyle/>
+          <a:p>
+            <a:pPr marL="0" indent="0">
+              <a:buNone/>
+            </a:pPr>
+            <a:r>
+              <a:rPr lang="en-US" sz="1300" b="1" dirty="0">
+                <a:solidFill>
+                  <a:srgbClr val="0D1B2A"/>
+                </a:solidFill>
+                <a:latin typeface="Calibri" pitchFamily="34" charset="0"/>
+              </a:rPr>
+              <a:t>Why LR Suits This Problem</a:t>
+            </a:r>
+          </a:p>
+        </p:txBody>
+      </p:sp>
+      <p:sp>
+        <p:nvSpPr>
+          <p:cNvPr id="11" name="RB"/>
+          <p:cNvSpPr/>
+          <p:nvPr/>
+        </p:nvSpPr>
+        <p:spPr>
+          <a:xfrm>
+            <a:off x="4709160" y="1080000"/>
+            <a:ext cx="4160880" cy="1440000"/>
+          </a:xfrm>
+          <a:prstGeom prst="rect">
+            <a:avLst/>
+          </a:prstGeom>
+          <a:noFill/>
+          <a:ln/>
+        </p:spPr>
+        <p:txBody>
+          <a:bodyPr wrap="square" lIns="0" tIns="0" rIns="0" bIns="0" rtlCol="0" anchor="t"/>
+          <a:lstStyle/>
+          <a:p>
+            <a:pPr marL="342900" indent="-342900">
+              <a:buSzPct val="100000"/>
+              <a:buChar char="•"/>
+            </a:pPr>
+            <a:r>
+              <a:rPr lang="en-US" sz="1050" dirty="0">
+                <a:solidFill>
+                  <a:srgbClr val="334155"/>
+                </a:solidFill>
+                <a:latin typeface="Calibri" pitchFamily="34" charset="0"/>
+              </a:rPr>
+              <a:t>Coefficients reveal which URL features most distinguish malicious from benign — directly answering the project question</a:t>
+            </a:r>
+          </a:p>
+          <a:p>
+            <a:pPr marL="342900" indent="-342900">
+              <a:buSzPct val="100000"/>
+              <a:buChar char="•"/>
+            </a:pPr>
+            <a:r>
+              <a:rPr lang="en-US" sz="1050" dirty="0">
+                <a:solidFill>
+                  <a:srgbClr val="334155"/>
+                </a:solidFill>
+                <a:latin typeface="Calibri" pitchFamily="34" charset="0"/>
+              </a:rPr>
+              <a:t>Balanced class weights directly counter the 18:1 imbalance — minority classes are not ignored</a:t>
+            </a:r>
+          </a:p>
+          <a:p>
+            <a:pPr marL="342900" indent="-342900">
+              <a:buSzPct val="100000"/>
+              <a:buChar char="•"/>
+            </a:pPr>
+            <a:r>
+              <a:rPr lang="en-US" sz="1050" dirty="0">
+                <a:solidFill>
+                  <a:srgbClr val="334155"/>
+                </a:solidFill>
+                <a:latin typeface="Calibri" pitchFamily="34" charset="0"/>
+              </a:rPr>
+              <a:t>Fast to train — practical for the 64K-sample training set used here</a:t>
+            </a:r>
+          </a:p>
+        </p:txBody>
+      </p:sp>
+      <p:sp>
+        <p:nvSpPr>
+          <p:cNvPr id="12" name="RoleBox"/>
+          <p:cNvSpPr/>
+          <p:nvPr/>
+        </p:nvSpPr>
+        <p:spPr>
+          <a:xfrm>
+            <a:off x="4709160" y="2620000"/>
+            <a:ext cx="4160880" cy="1060000"/>
+          </a:xfrm>
+          <a:prstGeom prst="rect">
+            <a:avLst/>
+          </a:prstGeom>
+          <a:solidFill>
+            <a:srgbClr val="CADCFC"/>
+          </a:solidFill>
+          <a:ln w="9525">
+            <a:solidFill>
+              <a:srgbClr val="1B2A41"/>
+            </a:solidFill>
+            <a:prstDash val="solid"/>
+          </a:ln>
+        </p:spPr>
+        <p:txBody>
+          <a:bodyPr wrap="square" lIns="91440" tIns="91440" rIns="91440" bIns="91440" rtlCol="0" anchor="t"/>
+          <a:lstStyle/>
+          <a:p>
+            <a:pPr marL="0" indent="0">
+              <a:buNone/>
+            </a:pPr>
+            <a:r>
+              <a:rPr lang="en-US" sz="1050" b="1" dirty="0">
+                <a:solidFill>
+                  <a:srgbClr val="0D1B2A"/>
+                </a:solidFill>
+                <a:latin typeface="Calibri" pitchFamily="34" charset="0"/>
+              </a:rPr>
+              <a:t>Role in this project</a:t>
+            </a:r>
+          </a:p>
+          <a:p>
+            <a:pPr marL="342900" indent="-342900">
+              <a:buSzPct val="100000"/>
+              <a:buChar char="•"/>
+            </a:pPr>
+            <a:r>
+              <a:rPr lang="en-US" sz="1000" dirty="0">
+                <a:solidFill>
+                  <a:srgbClr val="334155"/>
+                </a:solidFill>
+                <a:latin typeface="Calibri" pitchFamily="34" charset="0"/>
+              </a:rPr>
+              <a:t>The </a:t>
+            </a:r>
+            <a:r>
+              <a:rPr lang="en-US" sz="1000" b="1" dirty="0">
+                <a:solidFill>
+                  <a:srgbClr val="334155"/>
+                </a:solidFill>
+                <a:latin typeface="Calibri" pitchFamily="34" charset="0"/>
+              </a:rPr>
+              <a:t>interpretable</a:t>
+            </a:r>
+            <a:r>
+              <a:rPr lang="en-US" sz="1000" dirty="0">
+                <a:solidFill>
+                  <a:srgbClr val="334155"/>
+                </a:solidFill>
+                <a:latin typeface="Calibri" pitchFamily="34" charset="0"/>
+              </a:rPr>
+              <a:t> model — weaker predictor than k-NN but explains which features drive the classification decision</a:t>
+            </a:r>
+          </a:p>
+          <a:p>
+            <a:pPr marL="342900" indent="-342900">
+              <a:buSzPct val="100000"/>
+              <a:buChar char="•"/>
+            </a:pPr>
+            <a:r>
+              <a:rPr lang="en-US" sz="1000" dirty="0">
+                <a:solidFill>
+                  <a:srgbClr val="334155"/>
+                </a:solidFill>
+                <a:latin typeface="Calibri" pitchFamily="34" charset="0"/>
+              </a:rPr>
+              <a:t>Bal Acc 0.843 (binary) — respectable but k-NN scores 0.935</a:t>
+            </a:r>
+          </a:p>
+        </p:txBody>
+      </p:sp>
+    </p:spTree>
+  </p:cSld>
+  <p:clrMapOvr>
+    <a:masterClrMapping/>
+  </p:clrMapOvr>
+</p:sld>
+</file>
+
+<file path=ppt/slides/slide11.xml><?xml version="1.0" encoding="utf-8"?>
+<p:sld xmlns:a="http://schemas.openxmlformats.org/drawingml/2006/main" xmlns:r="http://schemas.openxmlformats.org/officeDocument/2006/relationships" xmlns:p="http://schemas.openxmlformats.org/presentationml/2006/main">
   <p:cSld name="Slide 6">
     <p:bg>
       <p:bgPr>
@@ -5617,7 +6220,7 @@
 </p:sld>
 </file>
 
-<file path=ppt/slides/slide11.xml><?xml version="1.0" encoding="utf-8"?>
+<file path=ppt/slides/slide12.xml><?xml version="1.0" encoding="utf-8"?>
 <p:sld xmlns:a="http://schemas.openxmlformats.org/drawingml/2006/main" xmlns:r="http://schemas.openxmlformats.org/officeDocument/2006/relationships" xmlns:p="http://schemas.openxmlformats.org/presentationml/2006/main">
   <p:cSld name="Slide 16">
     <p:bg>
@@ -6121,7 +6724,7 @@
 </p:sld>
 </file>
 
-<file path=ppt/slides/slide12.xml><?xml version="1.0" encoding="utf-8"?>
+<file path=ppt/slides/slide13.xml><?xml version="1.0" encoding="utf-8"?>
 <p:sld xmlns:a="http://schemas.openxmlformats.org/drawingml/2006/main" xmlns:r="http://schemas.openxmlformats.org/officeDocument/2006/relationships" xmlns:p="http://schemas.openxmlformats.org/presentationml/2006/main">
   <p:cSld name="Slide 7">
     <p:bg>
@@ -7820,7 +8423,7 @@
                 <a:ea typeface="Calibri" pitchFamily="34" charset="-122"/>
                 <a:cs typeface="Calibri" pitchFamily="34" charset="-120"/>
               </a:rPr>
-              <a:t>These are associations in this dataset, not causal rules. 'has_scheme' being the strongest positive predictor reflects that malware and defacement URLs almost always include http/https, while most benign URLs in this dataset do not. Context matters.</a:t>
+              <a:t>These are associations in this dataset, not causal rules. 'has_scheme' being the strongest positive predictor reflects that malware and defacement URLs almost always include http/https, while most benign URLs in this dataset do not.</a:t>
             </a:r>
             <a:endParaRPr lang="en-US" sz="950" dirty="0"/>
           </a:p>
@@ -7834,7 +8437,7 @@
 </p:sld>
 </file>
 
-<file path=ppt/slides/slide13.xml><?xml version="1.0" encoding="utf-8"?>
+<file path=ppt/slides/slide14.xml><?xml version="1.0" encoding="utf-8"?>
 <p:sld xmlns:a="http://schemas.openxmlformats.org/drawingml/2006/main" xmlns:r="http://schemas.openxmlformats.org/officeDocument/2006/relationships" xmlns:p="http://schemas.openxmlformats.org/presentationml/2006/main">
   <p:cSld name="Slide 8">
     <p:bg>
@@ -10660,7 +11263,7 @@
 </p:sld>
 </file>
 
-<file path=ppt/slides/slide14.xml><?xml version="1.0" encoding="utf-8"?>
+<file path=ppt/slides/slide15.xml><?xml version="1.0" encoding="utf-8"?>
 <p:sld xmlns:a="http://schemas.openxmlformats.org/drawingml/2006/main" xmlns:r="http://schemas.openxmlformats.org/officeDocument/2006/relationships" xmlns:p="http://schemas.openxmlformats.org/presentationml/2006/main">
   <p:cSld name="Slide 17">
     <p:bg>
@@ -11152,7 +11755,7 @@
 </p:sld>
 </file>
 
-<file path=ppt/slides/slide15.xml><?xml version="1.0" encoding="utf-8"?>
+<file path=ppt/slides/slide16.xml><?xml version="1.0" encoding="utf-8"?>
 <p:sld xmlns:a="http://schemas.openxmlformats.org/drawingml/2006/main" xmlns:r="http://schemas.openxmlformats.org/officeDocument/2006/relationships" xmlns:p="http://schemas.openxmlformats.org/presentationml/2006/main">
   <p:cSld name="Slide 9">
     <p:bg>
@@ -11840,7 +12443,7 @@
 </p:sld>
 </file>
 
-<file path=ppt/slides/slide16.xml><?xml version="1.0" encoding="utf-8"?>
+<file path=ppt/slides/slide17.xml><?xml version="1.0" encoding="utf-8"?>
 <p:sld xmlns:a="http://schemas.openxmlformats.org/drawingml/2006/main" xmlns:r="http://schemas.openxmlformats.org/officeDocument/2006/relationships" xmlns:p="http://schemas.openxmlformats.org/presentationml/2006/main">
   <p:cSld name="Slide 10">
     <p:bg>
@@ -12732,7 +13335,7 @@
 </p:sld>
 </file>
 
-<file path=ppt/slides/slide17.xml><?xml version="1.0" encoding="utf-8"?>
+<file path=ppt/slides/slide18.xml><?xml version="1.0" encoding="utf-8"?>
 <p:sld xmlns:a="http://schemas.openxmlformats.org/drawingml/2006/main" xmlns:r="http://schemas.openxmlformats.org/officeDocument/2006/relationships" xmlns:p="http://schemas.openxmlformats.org/presentationml/2006/main">
   <p:cSld name="Slide 11">
     <p:bg>
@@ -20552,63 +21155,6 @@
       </p:sp>
       <p:sp>
         <p:nvSpPr>
-          <p:cNvPr id="8" name="LeftCallout"/>
-          <p:cNvSpPr/>
-          <p:nvPr/>
-        </p:nvSpPr>
-        <p:spPr>
-          <a:xfrm>
-            <a:off x="320040" y="2840000"/>
-            <a:ext cx="4114800" cy="660000"/>
-          </a:xfrm>
-          <a:prstGeom prst="rect">
-            <a:avLst/>
-          </a:prstGeom>
-          <a:solidFill>
-            <a:srgbClr val="FDECEA"/>
-          </a:solidFill>
-          <a:ln w="9525">
-            <a:solidFill>
-              <a:srgbClr val="C0392B"/>
-            </a:solidFill>
-            <a:prstDash val="solid"/>
-          </a:ln>
-        </p:spPr>
-        <p:txBody>
-          <a:bodyPr wrap="square" lIns="91440" tIns="91440" rIns="91440" bIns="91440" rtlCol="0" anchor="ctr"/>
-          <a:lstStyle/>
-          <a:p>
-            <a:pPr marL="0" indent="0">
-              <a:buNone/>
-            </a:pPr>
-            <a:r>
-              <a:rPr lang="en-US" sz="950" b="1" dirty="0">
-                <a:solidFill>
-                  <a:srgbClr val="C0392B"/>
-                </a:solidFill>
-                <a:latin typeface="Calibri" pitchFamily="34" charset="0"/>
-              </a:rPr>
-              <a:t>Majority Baseline: Bal Acc = 0.500, Macro F1 = 0.400</a:t>
-            </a:r>
-          </a:p>
-          <a:p>
-            <a:pPr marL="0" indent="0">
-              <a:buNone/>
-            </a:pPr>
-            <a:r>
-              <a:rPr lang="en-US" sz="950" dirty="0">
-                <a:solidFill>
-                  <a:srgbClr val="334155"/>
-                </a:solidFill>
-                <a:latin typeface="Calibri" pitchFamily="34" charset="0"/>
-              </a:rPr>
-              <a:t>Always predicts benign — 0% recall on malicious</a:t>
-            </a:r>
-          </a:p>
-        </p:txBody>
-      </p:sp>
-      <p:sp>
-        <p:nvSpPr>
           <p:cNvPr id="9" name="Divider"/>
           <p:cNvSpPr/>
           <p:nvPr/>
@@ -20681,7 +21227,7 @@
         <p:spPr>
           <a:xfrm>
             <a:off x="4709160" y="1080000"/>
-            <a:ext cx="4114800" cy="830000"/>
+            <a:ext cx="4114800" cy="704039"/>
           </a:xfrm>
           <a:prstGeom prst="rect">
             <a:avLst/>
@@ -20731,7 +21277,7 @@
                 </a:solidFill>
                 <a:latin typeface="Calibri" pitchFamily="34" charset="0"/>
               </a:rPr>
-              <a:t>Average recall across all classes. A model that ignores the malware class scores 0.50 — not higher. Fair regardless of class size.</a:t>
+              <a:t>This is the average recall across all the classes. A model that ignores the malware class scores 0.50 — not higher. Fair regardless of class size.</a:t>
             </a:r>
           </a:p>
         </p:txBody>
@@ -20744,8 +21290,8 @@
         </p:nvSpPr>
         <p:spPr>
           <a:xfrm>
-            <a:off x="4709160" y="1980000"/>
-            <a:ext cx="4114800" cy="900000"/>
+            <a:off x="4709160" y="1920000"/>
+            <a:ext cx="4114800" cy="780000"/>
           </a:xfrm>
           <a:prstGeom prst="rect">
             <a:avLst/>
@@ -20795,7 +21341,7 @@
                 </a:solidFill>
                 <a:latin typeface="Calibri" pitchFamily="34" charset="0"/>
               </a:rPr>
-              <a:t>F1 = harmonic mean of precision and recall. Macro = averaged equally across all classes. Penalises poor performance on small classes like malware (3.7% of data).</a:t>
+              <a:t>F1 = Harmonic mean of precision and recall. Macro = averaged equally across all classes. Penalises poor performance on small classes like malware (3.7% of data).</a:t>
             </a:r>
           </a:p>
         </p:txBody>
@@ -20808,8 +21354,8 @@
         </p:nvSpPr>
         <p:spPr>
           <a:xfrm>
-            <a:off x="4709160" y="2960000"/>
-            <a:ext cx="4114800" cy="540000"/>
+            <a:off x="4709160" y="2787481"/>
+            <a:ext cx="4114800" cy="420000"/>
           </a:xfrm>
           <a:prstGeom prst="rect">
             <a:avLst/>
@@ -20840,6 +21386,218 @@
               </a:rPr>
               <a:t>Both metrics treat every class equally — essential when catching phishing or malware matters as much as classifying benign URLs.</a:t>
             </a:r>
+          </a:p>
+        </p:txBody>
+      </p:sp>
+      <p:sp>
+        <p:nvSpPr>
+          <p:cNvPr id="14" name="MacroF1Card">
+            <a:extLst>
+              <a:ext uri="{FF2B5EF4-FFF2-40B4-BE49-F238E27FC236}">
+                <a16:creationId xmlns:a16="http://schemas.microsoft.com/office/drawing/2014/main" id="{318DEADA-502D-4AF9-A473-314A89B07446}"/>
+              </a:ext>
+            </a:extLst>
+          </p:cNvPr>
+          <p:cNvSpPr/>
+          <p:nvPr/>
+        </p:nvSpPr>
+        <p:spPr>
+          <a:xfrm>
+            <a:off x="4709160" y="3302085"/>
+            <a:ext cx="4114800" cy="631632"/>
+          </a:xfrm>
+          <a:prstGeom prst="rect">
+            <a:avLst/>
+          </a:prstGeom>
+          <a:solidFill>
+            <a:srgbClr val="E8F4F8"/>
+          </a:solidFill>
+          <a:ln w="9525">
+            <a:solidFill>
+              <a:srgbClr val="028090"/>
+            </a:solidFill>
+            <a:prstDash val="solid"/>
+          </a:ln>
+          <a:effectLst>
+            <a:outerShdw blurRad="101600" dist="38100" dir="8100000" algn="bl" rotWithShape="0">
+              <a:srgbClr val="000000">
+                <a:alpha val="12000"/>
+              </a:srgbClr>
+            </a:outerShdw>
+          </a:effectLst>
+        </p:spPr>
+        <p:txBody>
+          <a:bodyPr wrap="square" lIns="91440" tIns="91440" rIns="91440" bIns="91440" rtlCol="0" anchor="t"/>
+          <a:lstStyle/>
+          <a:p>
+            <a:pPr marL="0" indent="0">
+              <a:buNone/>
+            </a:pPr>
+            <a:r>
+              <a:rPr lang="en-US" sz="1050" b="1" dirty="0">
+                <a:solidFill>
+                  <a:srgbClr val="028090"/>
+                </a:solidFill>
+                <a:latin typeface="Calibri" pitchFamily="34" charset="0"/>
+              </a:rPr>
+              <a:t>Recall</a:t>
+            </a:r>
+          </a:p>
+          <a:p>
+            <a:pPr marL="0" marR="0" lvl="0" indent="0" algn="l" defTabSz="914400" rtl="0" eaLnBrk="1" fontAlgn="auto" latinLnBrk="0" hangingPunct="1">
+              <a:lnSpc>
+                <a:spcPct val="100000"/>
+              </a:lnSpc>
+              <a:spcBef>
+                <a:spcPts val="0"/>
+              </a:spcBef>
+              <a:spcAft>
+                <a:spcPts val="0"/>
+              </a:spcAft>
+              <a:buClrTx/>
+              <a:buSzTx/>
+              <a:buFontTx/>
+              <a:buNone/>
+              <a:tabLst/>
+              <a:defRPr/>
+            </a:pPr>
+            <a:r>
+              <a:rPr lang="en-GB" sz="1000" dirty="0">
+                <a:solidFill>
+                  <a:srgbClr val="334155"/>
+                </a:solidFill>
+                <a:latin typeface="Calibri" pitchFamily="34" charset="0"/>
+              </a:rPr>
+              <a:t>Out of all the truly malicious URLs, how many did we find? </a:t>
+            </a:r>
+            <a:endParaRPr kumimoji="0" lang="en-GB" sz="1000" b="0" i="0" u="none" strike="noStrike" kern="1200" cap="none" spc="0" normalizeH="0" baseline="0" noProof="0" dirty="0">
+              <a:ln>
+                <a:noFill/>
+              </a:ln>
+              <a:solidFill>
+                <a:srgbClr val="334155"/>
+              </a:solidFill>
+              <a:effectLst/>
+              <a:uLnTx/>
+              <a:uFillTx/>
+              <a:latin typeface="Calibri" pitchFamily="34" charset="0"/>
+              <a:ea typeface="+mn-ea"/>
+              <a:cs typeface="+mn-cs"/>
+            </a:endParaRPr>
+          </a:p>
+          <a:p>
+            <a:pPr marL="0" indent="0">
+              <a:buNone/>
+            </a:pPr>
+            <a:endParaRPr lang="en-US" sz="1150" b="1" dirty="0">
+              <a:solidFill>
+                <a:srgbClr val="028090"/>
+              </a:solidFill>
+              <a:latin typeface="Calibri" pitchFamily="34" charset="0"/>
+            </a:endParaRPr>
+          </a:p>
+        </p:txBody>
+      </p:sp>
+      <p:sp>
+        <p:nvSpPr>
+          <p:cNvPr id="15" name="MacroF1Card">
+            <a:extLst>
+              <a:ext uri="{FF2B5EF4-FFF2-40B4-BE49-F238E27FC236}">
+                <a16:creationId xmlns:a16="http://schemas.microsoft.com/office/drawing/2014/main" id="{CD67CC57-8F66-4C56-1BF8-AC513206CDCB}"/>
+              </a:ext>
+            </a:extLst>
+          </p:cNvPr>
+          <p:cNvSpPr/>
+          <p:nvPr/>
+        </p:nvSpPr>
+        <p:spPr>
+          <a:xfrm>
+            <a:off x="4709160" y="4063501"/>
+            <a:ext cx="4114800" cy="631632"/>
+          </a:xfrm>
+          <a:prstGeom prst="rect">
+            <a:avLst/>
+          </a:prstGeom>
+          <a:solidFill>
+            <a:srgbClr val="E8F4F8"/>
+          </a:solidFill>
+          <a:ln w="9525">
+            <a:solidFill>
+              <a:srgbClr val="028090"/>
+            </a:solidFill>
+            <a:prstDash val="solid"/>
+          </a:ln>
+          <a:effectLst>
+            <a:outerShdw blurRad="101600" dist="38100" dir="8100000" algn="bl" rotWithShape="0">
+              <a:srgbClr val="000000">
+                <a:alpha val="12000"/>
+              </a:srgbClr>
+            </a:outerShdw>
+          </a:effectLst>
+        </p:spPr>
+        <p:txBody>
+          <a:bodyPr wrap="square" lIns="91440" tIns="91440" rIns="91440" bIns="91440" rtlCol="0" anchor="t"/>
+          <a:lstStyle/>
+          <a:p>
+            <a:pPr marL="0" indent="0">
+              <a:buNone/>
+            </a:pPr>
+            <a:r>
+              <a:rPr lang="en-US" sz="1050" b="1" dirty="0">
+                <a:solidFill>
+                  <a:srgbClr val="028090"/>
+                </a:solidFill>
+                <a:latin typeface="Calibri" pitchFamily="34" charset="0"/>
+              </a:rPr>
+              <a:t>Precision</a:t>
+            </a:r>
+          </a:p>
+          <a:p>
+            <a:pPr marL="0" marR="0" lvl="0" indent="0" algn="l" defTabSz="914400" rtl="0" eaLnBrk="1" fontAlgn="auto" latinLnBrk="0" hangingPunct="1">
+              <a:lnSpc>
+                <a:spcPct val="100000"/>
+              </a:lnSpc>
+              <a:spcBef>
+                <a:spcPts val="0"/>
+              </a:spcBef>
+              <a:spcAft>
+                <a:spcPts val="0"/>
+              </a:spcAft>
+              <a:buClrTx/>
+              <a:buSzTx/>
+              <a:buFontTx/>
+              <a:buNone/>
+              <a:tabLst/>
+              <a:defRPr/>
+            </a:pPr>
+            <a:r>
+              <a:rPr kumimoji="0" lang="en-GB" sz="1000" b="0" i="0" u="none" strike="noStrike" kern="1200" cap="none" spc="0" normalizeH="0" baseline="0" noProof="0" dirty="0">
+                <a:ln>
+                  <a:noFill/>
+                </a:ln>
+                <a:solidFill>
+                  <a:srgbClr val="334155"/>
+                </a:solidFill>
+                <a:effectLst/>
+                <a:uLnTx/>
+                <a:uFillTx/>
+                <a:latin typeface="Calibri" pitchFamily="34" charset="0"/>
+                <a:ea typeface="+mn-ea"/>
+                <a:cs typeface="+mn-cs"/>
+              </a:rPr>
+              <a:t>Out of all the URLs the model predicted as malicious, how many were actually malicious? </a:t>
+            </a:r>
+          </a:p>
+          <a:p>
+            <a:pPr marL="0" indent="0">
+              <a:buNone/>
+            </a:pPr>
+            <a:endParaRPr lang="en-US" sz="1150" b="1" dirty="0">
+              <a:solidFill>
+                <a:srgbClr val="028090"/>
+              </a:solidFill>
+              <a:latin typeface="Calibri" pitchFamily="34" charset="0"/>
+            </a:endParaRPr>
           </a:p>
         </p:txBody>
       </p:sp>
@@ -23912,38 +24670,6 @@
       </p:sp>
       <p:sp>
         <p:nvSpPr>
-          <p:cNvPr id="44" name="Shape 42"/>
-          <p:cNvSpPr/>
-          <p:nvPr/>
-        </p:nvSpPr>
-        <p:spPr>
-          <a:xfrm>
-            <a:off x="320040" y="4315968"/>
-            <a:ext cx="8503920" cy="411480"/>
-          </a:xfrm>
-          <a:prstGeom prst="rect">
-            <a:avLst/>
-          </a:prstGeom>
-          <a:solidFill>
-            <a:srgbClr val="CADCFC"/>
-          </a:solidFill>
-          <a:ln w="6350">
-            <a:solidFill>
-              <a:srgbClr val="028090"/>
-            </a:solidFill>
-            <a:prstDash val="solid"/>
-          </a:ln>
-        </p:spPr>
-        <p:txBody>
-          <a:bodyPr/>
-          <a:lstStyle/>
-          <a:p>
-            <a:endParaRPr lang="en-IN"/>
-          </a:p>
-        </p:txBody>
-      </p:sp>
-      <p:sp>
-        <p:nvSpPr>
           <p:cNvPr id="45" name="Text 43"/>
           <p:cNvSpPr/>
           <p:nvPr/>
@@ -23966,17 +24692,6 @@
             <a:pPr marL="0" indent="0">
               <a:buNone/>
             </a:pPr>
-            <a:r>
-              <a:rPr lang="en-US" sz="950" dirty="0">
-                <a:solidFill>
-                  <a:srgbClr val="0D1B2A"/>
-                </a:solidFill>
-                <a:latin typeface="Calibri" pitchFamily="34" charset="0"/>
-                <a:ea typeface="Calibri" pitchFamily="34" charset="-122"/>
-                <a:cs typeface="Calibri" pitchFamily="34" charset="-120"/>
-              </a:rPr>
-              <a:t>Extended set = core + suspicious tokens. 3-fold CV chose extended for binary task (marginal gain: +0.0006 balanced acc). Numeric features standardized; class_weight=balanced used to handle imbalance.</a:t>
-            </a:r>
             <a:endParaRPr lang="en-US" sz="950" dirty="0"/>
           </a:p>
         </p:txBody>
@@ -23990,6 +24705,1156 @@
 </file>
 
 <file path=ppt/slides/slide7.xml><?xml version="1.0" encoding="utf-8"?>
+<p:sld xmlns:a="http://schemas.openxmlformats.org/drawingml/2006/main" xmlns:r="http://schemas.openxmlformats.org/officeDocument/2006/relationships" xmlns:p="http://schemas.openxmlformats.org/presentationml/2006/main">
+  <p:cSld>
+    <p:spTree>
+      <p:nvGrpSpPr>
+        <p:cNvPr id="1" name=""/>
+        <p:cNvGrpSpPr/>
+        <p:nvPr/>
+      </p:nvGrpSpPr>
+      <p:grpSpPr>
+        <a:xfrm>
+          <a:off x="0" y="0"/>
+          <a:ext cx="0" cy="0"/>
+          <a:chOff x="0" y="0"/>
+          <a:chExt cx="0" cy="0"/>
+        </a:xfrm>
+      </p:grpSpPr>
+      <p:sp>
+        <p:nvSpPr>
+          <p:cNvPr id="2" name="Shape 0"/>
+          <p:cNvSpPr/>
+          <p:nvPr/>
+        </p:nvSpPr>
+        <p:spPr>
+          <a:xfrm>
+            <a:off x="0" y="0"/>
+            <a:ext cx="9144000" cy="658368"/>
+          </a:xfrm>
+          <a:prstGeom prst="rect">
+            <a:avLst/>
+          </a:prstGeom>
+          <a:solidFill>
+            <a:srgbClr val="0D1B2A"/>
+          </a:solidFill>
+          <a:ln w="12700">
+            <a:solidFill>
+              <a:srgbClr val="0D1B2A"/>
+            </a:solidFill>
+            <a:prstDash val="solid"/>
+          </a:ln>
+        </p:spPr>
+        <p:txBody>
+          <a:bodyPr/>
+          <a:lstStyle/>
+          <a:p>
+            <a:endParaRPr lang="en-IN"/>
+          </a:p>
+        </p:txBody>
+      </p:sp>
+      <p:sp>
+        <p:nvSpPr>
+          <p:cNvPr id="3" name="Text 1"/>
+          <p:cNvSpPr/>
+          <p:nvPr/>
+        </p:nvSpPr>
+        <p:spPr>
+          <a:xfrm>
+            <a:off x="384048" y="0"/>
+            <a:ext cx="8412480" cy="658368"/>
+          </a:xfrm>
+          <a:prstGeom prst="rect">
+            <a:avLst/>
+          </a:prstGeom>
+          <a:noFill/>
+          <a:ln/>
+        </p:spPr>
+        <p:txBody>
+          <a:bodyPr wrap="square" lIns="0" tIns="0" rIns="0" bIns="0" rtlCol="0" anchor="ctr"/>
+          <a:lstStyle/>
+          <a:p>
+            <a:pPr marL="0" indent="0">
+              <a:buNone/>
+            </a:pPr>
+            <a:r>
+              <a:rPr lang="en-US" sz="2000" b="1" dirty="0">
+                <a:solidFill>
+                  <a:srgbClr val="FFFFFF"/>
+                </a:solidFill>
+                <a:latin typeface="Calibri" pitchFamily="34" charset="0"/>
+                <a:ea typeface="Calibri" pitchFamily="34" charset="-122"/>
+                <a:cs typeface="Calibri" pitchFamily="34" charset="-120"/>
+              </a:rPr>
+              <a:t>Feature Definitions: What Each Feature Measures</a:t>
+            </a:r>
+          </a:p>
+        </p:txBody>
+      </p:sp>
+      <p:sp>
+        <p:nvSpPr>
+          <p:cNvPr id="4" name="Shape 2"/>
+          <p:cNvSpPr/>
+          <p:nvPr/>
+        </p:nvSpPr>
+        <p:spPr>
+          <a:xfrm>
+            <a:off x="0" y="4892040"/>
+            <a:ext cx="9144000" cy="251460"/>
+          </a:xfrm>
+          <a:prstGeom prst="rect">
+            <a:avLst/>
+          </a:prstGeom>
+          <a:solidFill>
+            <a:srgbClr val="1B2A41"/>
+          </a:solidFill>
+          <a:ln w="12700">
+            <a:solidFill>
+              <a:srgbClr val="1B2A41"/>
+            </a:solidFill>
+            <a:prstDash val="solid"/>
+          </a:ln>
+        </p:spPr>
+        <p:txBody>
+          <a:bodyPr/>
+          <a:lstStyle/>
+          <a:p>
+            <a:endParaRPr lang="en-IN"/>
+          </a:p>
+        </p:txBody>
+      </p:sp>
+      <p:sp>
+        <p:nvSpPr>
+          <p:cNvPr id="5" name="Text 3"/>
+          <p:cNvSpPr/>
+          <p:nvPr/>
+        </p:nvSpPr>
+        <p:spPr>
+          <a:xfrm>
+            <a:off x="274320" y="4892040"/>
+            <a:ext cx="8595360" cy="251460"/>
+          </a:xfrm>
+          <a:prstGeom prst="rect">
+            <a:avLst/>
+          </a:prstGeom>
+          <a:noFill/>
+          <a:ln/>
+        </p:spPr>
+        <p:txBody>
+          <a:bodyPr wrap="square" lIns="0" tIns="0" rIns="0" bIns="0" rtlCol="0" anchor="ctr"/>
+          <a:lstStyle/>
+          <a:p>
+            <a:pPr marL="0" indent="0">
+              <a:buNone/>
+            </a:pPr>
+            <a:r>
+              <a:rPr lang="en-US" sz="800" dirty="0">
+                <a:solidFill>
+                  <a:srgbClr val="CADCFC"/>
+                </a:solidFill>
+                <a:latin typeface="Calibri" pitchFamily="34" charset="0"/>
+                <a:ea typeface="Calibri" pitchFamily="34" charset="-122"/>
+                <a:cs typeface="Calibri" pitchFamily="34" charset="-120"/>
+              </a:rPr>
+              <a:t>Malicious URL Detection · Lexical Features Only  |  Feature Engineering · Feature Definitions</a:t>
+            </a:r>
+          </a:p>
+        </p:txBody>
+      </p:sp>
+      <p:sp>
+        <p:nvSpPr>
+          <p:cNvPr id="6" name="Shape LS Bar"/>
+          <p:cNvSpPr/>
+          <p:nvPr/>
+        </p:nvSpPr>
+        <p:spPr>
+          <a:xfrm>
+            <a:off x="320040" y="730000"/>
+            <a:ext cx="54864" cy="1870000"/>
+          </a:xfrm>
+          <a:prstGeom prst="rect">
+            <a:avLst/>
+          </a:prstGeom>
+          <a:solidFill>
+            <a:srgbClr val="028090"/>
+          </a:solidFill>
+          <a:ln w="12700">
+            <a:solidFill>
+              <a:srgbClr val="028090"/>
+            </a:solidFill>
+            <a:prstDash val="solid"/>
+          </a:ln>
+        </p:spPr>
+        <p:txBody>
+          <a:bodyPr/>
+          <a:lstStyle/>
+          <a:p>
+            <a:endParaRPr lang="en-IN"/>
+          </a:p>
+        </p:txBody>
+      </p:sp>
+      <p:sp>
+        <p:nvSpPr>
+          <p:cNvPr id="7" name="Text LS Header"/>
+          <p:cNvSpPr/>
+          <p:nvPr/>
+        </p:nvSpPr>
+        <p:spPr>
+          <a:xfrm>
+            <a:off x="438912" y="730000"/>
+            <a:ext cx="4389120" cy="240000"/>
+          </a:xfrm>
+          <a:prstGeom prst="rect">
+            <a:avLst/>
+          </a:prstGeom>
+          <a:noFill/>
+          <a:ln/>
+        </p:spPr>
+        <p:txBody>
+          <a:bodyPr wrap="square" lIns="0" tIns="0" rIns="0" bIns="0" rtlCol="0" anchor="ctr"/>
+          <a:lstStyle/>
+          <a:p>
+            <a:pPr marL="0" indent="0">
+              <a:buNone/>
+            </a:pPr>
+            <a:r>
+              <a:rPr lang="en-US" sz="1050" b="1" dirty="0">
+                <a:solidFill>
+                  <a:srgbClr val="0D1B2A"/>
+                </a:solidFill>
+                <a:latin typeface="Calibri" pitchFamily="34" charset="0"/>
+                <a:ea typeface="Calibri" pitchFamily="34" charset="-122"/>
+                <a:cs typeface="Calibri" pitchFamily="34" charset="-120"/>
+              </a:rPr>
+              <a:t>Length &amp; Structure</a:t>
+            </a:r>
+          </a:p>
+        </p:txBody>
+      </p:sp>
+      <p:sp>
+        <p:nvSpPr>
+          <p:cNvPr id="8" name="Text url_length"/>
+          <p:cNvSpPr/>
+          <p:nvPr/>
+        </p:nvSpPr>
+        <p:spPr>
+          <a:xfrm>
+            <a:off x="438912" y="990000"/>
+            <a:ext cx="4389120" cy="390000"/>
+          </a:xfrm>
+          <a:prstGeom prst="rect">
+            <a:avLst/>
+          </a:prstGeom>
+          <a:noFill/>
+          <a:ln/>
+        </p:spPr>
+        <p:txBody>
+          <a:bodyPr wrap="square" lIns="0" tIns="0" rIns="0" bIns="0" rtlCol="0" anchor="t"/>
+          <a:lstStyle/>
+          <a:p>
+            <a:pPr marL="0" indent="0">
+              <a:buNone/>
+            </a:pPr>
+            <a:r>
+              <a:rPr lang="en-US" sz="950" b="1" dirty="0">
+                <a:solidFill>
+                  <a:srgbClr val="028090"/>
+                </a:solidFill>
+                <a:latin typeface="Calibri" pitchFamily="34" charset="0"/>
+              </a:rPr>
+              <a:t>url_length</a:t>
+            </a:r>
+            <a:r>
+              <a:rPr lang="en-US" sz="950" dirty="0">
+                <a:solidFill>
+                  <a:srgbClr val="374151"/>
+                </a:solidFill>
+                <a:latin typeface="Calibri" pitchFamily="34" charset="0"/>
+              </a:rPr>
+              <a:t> — total characters in the full URL (e.g. http://abc.com/login is longer than abc.com).</a:t>
+            </a:r>
+          </a:p>
+        </p:txBody>
+      </p:sp>
+      <p:sp>
+        <p:nvSpPr>
+          <p:cNvPr id="9" name="Text host_length"/>
+          <p:cNvSpPr/>
+          <p:nvPr/>
+        </p:nvSpPr>
+        <p:spPr>
+          <a:xfrm>
+            <a:off x="438912" y="1390000"/>
+            <a:ext cx="4389120" cy="390000"/>
+          </a:xfrm>
+          <a:prstGeom prst="rect">
+            <a:avLst/>
+          </a:prstGeom>
+          <a:noFill/>
+          <a:ln/>
+        </p:spPr>
+        <p:txBody>
+          <a:bodyPr wrap="square" lIns="0" tIns="0" rIns="0" bIns="0" rtlCol="0" anchor="t"/>
+          <a:lstStyle/>
+          <a:p>
+            <a:pPr marL="0" indent="0">
+              <a:buNone/>
+            </a:pPr>
+            <a:r>
+              <a:rPr lang="en-US" sz="950" b="1" dirty="0">
+                <a:solidFill>
+                  <a:srgbClr val="028090"/>
+                </a:solidFill>
+                <a:latin typeface="Calibri" pitchFamily="34" charset="0"/>
+              </a:rPr>
+              <a:t>host_length</a:t>
+            </a:r>
+            <a:r>
+              <a:rPr lang="en-US" sz="950" dirty="0">
+                <a:solidFill>
+                  <a:srgbClr val="374151"/>
+                </a:solidFill>
+                <a:latin typeface="Calibri" pitchFamily="34" charset="0"/>
+              </a:rPr>
+              <a:t> — characters in the domain/host (e.g. secure-paypal-login.com is longer than google.com).</a:t>
+            </a:r>
+          </a:p>
+        </p:txBody>
+      </p:sp>
+      <p:sp>
+        <p:nvSpPr>
+          <p:cNvPr id="10" name="Text path_length"/>
+          <p:cNvSpPr/>
+          <p:nvPr/>
+        </p:nvSpPr>
+        <p:spPr>
+          <a:xfrm>
+            <a:off x="438912" y="1790000"/>
+            <a:ext cx="4389120" cy="390000"/>
+          </a:xfrm>
+          <a:prstGeom prst="rect">
+            <a:avLst/>
+          </a:prstGeom>
+          <a:noFill/>
+          <a:ln/>
+        </p:spPr>
+        <p:txBody>
+          <a:bodyPr wrap="square" lIns="0" tIns="0" rIns="0" bIns="0" rtlCol="0" anchor="t"/>
+          <a:lstStyle/>
+          <a:p>
+            <a:pPr marL="0" indent="0">
+              <a:buNone/>
+            </a:pPr>
+            <a:r>
+              <a:rPr lang="en-US" sz="950" b="1" dirty="0">
+                <a:solidFill>
+                  <a:srgbClr val="028090"/>
+                </a:solidFill>
+                <a:latin typeface="Calibri" pitchFamily="34" charset="0"/>
+              </a:rPr>
+              <a:t>path_length</a:t>
+            </a:r>
+            <a:r>
+              <a:rPr lang="en-US" sz="950" dirty="0">
+                <a:solidFill>
+                  <a:srgbClr val="374151"/>
+                </a:solidFill>
+                <a:latin typeface="Calibri" pitchFamily="34" charset="0"/>
+              </a:rPr>
+              <a:t> — characters in the path after the domain (e.g. /account/verify/update is a long path).</a:t>
+            </a:r>
+          </a:p>
+        </p:txBody>
+      </p:sp>
+      <p:sp>
+        <p:nvSpPr>
+          <p:cNvPr id="11" name="Text query_length"/>
+          <p:cNvSpPr/>
+          <p:nvPr/>
+        </p:nvSpPr>
+        <p:spPr>
+          <a:xfrm>
+            <a:off x="438912" y="2190000"/>
+            <a:ext cx="4389120" cy="400000"/>
+          </a:xfrm>
+          <a:prstGeom prst="rect">
+            <a:avLst/>
+          </a:prstGeom>
+          <a:noFill/>
+          <a:ln/>
+        </p:spPr>
+        <p:txBody>
+          <a:bodyPr wrap="square" lIns="0" tIns="0" rIns="0" bIns="0" rtlCol="0" anchor="t"/>
+          <a:lstStyle/>
+          <a:p>
+            <a:pPr marL="0" indent="0">
+              <a:buNone/>
+            </a:pPr>
+            <a:r>
+              <a:rPr lang="en-US" sz="950" b="1" dirty="0">
+                <a:solidFill>
+                  <a:srgbClr val="028090"/>
+                </a:solidFill>
+                <a:latin typeface="Calibri" pitchFamily="34" charset="0"/>
+              </a:rPr>
+              <a:t>query_length</a:t>
+            </a:r>
+            <a:r>
+              <a:rPr lang="en-US" sz="950" dirty="0">
+                <a:solidFill>
+                  <a:srgbClr val="374151"/>
+                </a:solidFill>
+                <a:latin typeface="Calibri" pitchFamily="34" charset="0"/>
+              </a:rPr>
+              <a:t> — characters in the query string after ? (e.g. in site.com/page?id=123&amp;user=abc, the part after ? is the query).</a:t>
+            </a:r>
+          </a:p>
+        </p:txBody>
+      </p:sp>
+      <p:sp>
+        <p:nvSpPr>
+          <p:cNvPr id="12" name="Shape CS Bar"/>
+          <p:cNvSpPr/>
+          <p:nvPr/>
+        </p:nvSpPr>
+        <p:spPr>
+          <a:xfrm>
+            <a:off x="320040" y="2710000"/>
+            <a:ext cx="54864" cy="1870000"/>
+          </a:xfrm>
+          <a:prstGeom prst="rect">
+            <a:avLst/>
+          </a:prstGeom>
+          <a:solidFill>
+            <a:srgbClr val="F59E0B"/>
+          </a:solidFill>
+          <a:ln w="12700">
+            <a:solidFill>
+              <a:srgbClr val="F59E0B"/>
+            </a:solidFill>
+            <a:prstDash val="solid"/>
+          </a:ln>
+        </p:spPr>
+        <p:txBody>
+          <a:bodyPr/>
+          <a:lstStyle/>
+          <a:p>
+            <a:endParaRPr lang="en-IN"/>
+          </a:p>
+        </p:txBody>
+      </p:sp>
+      <p:sp>
+        <p:nvSpPr>
+          <p:cNvPr id="13" name="Text CS Header"/>
+          <p:cNvSpPr/>
+          <p:nvPr/>
+        </p:nvSpPr>
+        <p:spPr>
+          <a:xfrm>
+            <a:off x="438912" y="2710000"/>
+            <a:ext cx="4389120" cy="240000"/>
+          </a:xfrm>
+          <a:prstGeom prst="rect">
+            <a:avLst/>
+          </a:prstGeom>
+          <a:noFill/>
+          <a:ln/>
+        </p:spPr>
+        <p:txBody>
+          <a:bodyPr wrap="square" lIns="0" tIns="0" rIns="0" bIns="0" rtlCol="0" anchor="ctr"/>
+          <a:lstStyle/>
+          <a:p>
+            <a:pPr marL="0" indent="0">
+              <a:buNone/>
+            </a:pPr>
+            <a:r>
+              <a:rPr lang="en-US" sz="1050" b="1" dirty="0">
+                <a:solidFill>
+                  <a:srgbClr val="0D1B2A"/>
+                </a:solidFill>
+                <a:latin typeface="Calibri" pitchFamily="34" charset="0"/>
+                <a:ea typeface="Calibri" pitchFamily="34" charset="-122"/>
+                <a:cs typeface="Calibri" pitchFamily="34" charset="-120"/>
+              </a:rPr>
+              <a:t>Counts &amp; Symbols</a:t>
+            </a:r>
+          </a:p>
+        </p:txBody>
+      </p:sp>
+      <p:sp>
+        <p:nvSpPr>
+          <p:cNvPr id="14" name="Text subdomain_count"/>
+          <p:cNvSpPr/>
+          <p:nvPr/>
+        </p:nvSpPr>
+        <p:spPr>
+          <a:xfrm>
+            <a:off x="438912" y="2970000"/>
+            <a:ext cx="4389120" cy="390000"/>
+          </a:xfrm>
+          <a:prstGeom prst="rect">
+            <a:avLst/>
+          </a:prstGeom>
+          <a:noFill/>
+          <a:ln/>
+        </p:spPr>
+        <p:txBody>
+          <a:bodyPr wrap="square" lIns="0" tIns="0" rIns="0" bIns="0" rtlCol="0" anchor="t"/>
+          <a:lstStyle/>
+          <a:p>
+            <a:pPr marL="0" indent="0">
+              <a:buNone/>
+            </a:pPr>
+            <a:r>
+              <a:rPr lang="en-US" sz="950" b="1" dirty="0">
+                <a:solidFill>
+                  <a:srgbClr val="F59E0B"/>
+                </a:solidFill>
+                <a:latin typeface="Calibri" pitchFamily="34" charset="0"/>
+              </a:rPr>
+              <a:t>subdomain_count</a:t>
+            </a:r>
+            <a:r>
+              <a:rPr lang="en-US" sz="950" dirty="0">
+                <a:solidFill>
+                  <a:srgbClr val="374151"/>
+                </a:solidFill>
+                <a:latin typeface="Calibri" pitchFamily="34" charset="0"/>
+              </a:rPr>
+              <a:t> — subdomain levels before the main domain (e.g. mail.login.bank.com has more than bank.com).</a:t>
+            </a:r>
+          </a:p>
+        </p:txBody>
+      </p:sp>
+      <p:sp>
+        <p:nvSpPr>
+          <p:cNvPr id="15" name="Text hyphen_count"/>
+          <p:cNvSpPr/>
+          <p:nvPr/>
+        </p:nvSpPr>
+        <p:spPr>
+          <a:xfrm>
+            <a:off x="438912" y="3370000"/>
+            <a:ext cx="4389120" cy="390000"/>
+          </a:xfrm>
+          <a:prstGeom prst="rect">
+            <a:avLst/>
+          </a:prstGeom>
+          <a:noFill/>
+          <a:ln/>
+        </p:spPr>
+        <p:txBody>
+          <a:bodyPr wrap="square" lIns="0" tIns="0" rIns="0" bIns="0" rtlCol="0" anchor="t"/>
+          <a:lstStyle/>
+          <a:p>
+            <a:pPr marL="0" indent="0">
+              <a:buNone/>
+            </a:pPr>
+            <a:r>
+              <a:rPr lang="en-US" sz="950" b="1" dirty="0">
+                <a:solidFill>
+                  <a:srgbClr val="F59E0B"/>
+                </a:solidFill>
+                <a:latin typeface="Calibri" pitchFamily="34" charset="0"/>
+              </a:rPr>
+              <a:t>hyphen_count</a:t>
+            </a:r>
+            <a:r>
+              <a:rPr lang="en-US" sz="950" dirty="0">
+                <a:solidFill>
+                  <a:srgbClr val="374151"/>
+                </a:solidFill>
+                <a:latin typeface="Calibri" pitchFamily="34" charset="0"/>
+              </a:rPr>
+              <a:t> — number of hyphens in the URL (e.g. free-login-secure-site.com has many hyphens).</a:t>
+            </a:r>
+          </a:p>
+        </p:txBody>
+      </p:sp>
+      <p:sp>
+        <p:nvSpPr>
+          <p:cNvPr id="16" name="Text has_at_symbol"/>
+          <p:cNvSpPr/>
+          <p:nvPr/>
+        </p:nvSpPr>
+        <p:spPr>
+          <a:xfrm>
+            <a:off x="438912" y="3770000"/>
+            <a:ext cx="4389120" cy="390000"/>
+          </a:xfrm>
+          <a:prstGeom prst="rect">
+            <a:avLst/>
+          </a:prstGeom>
+          <a:noFill/>
+          <a:ln/>
+        </p:spPr>
+        <p:txBody>
+          <a:bodyPr wrap="square" lIns="0" tIns="0" rIns="0" bIns="0" rtlCol="0" anchor="t"/>
+          <a:lstStyle/>
+          <a:p>
+            <a:pPr marL="0" indent="0">
+              <a:buNone/>
+            </a:pPr>
+            <a:r>
+              <a:rPr lang="en-US" sz="950" b="1" dirty="0">
+                <a:solidFill>
+                  <a:srgbClr val="F59E0B"/>
+                </a:solidFill>
+                <a:latin typeface="Calibri" pitchFamily="34" charset="0"/>
+              </a:rPr>
+              <a:t>has_at_symbol</a:t>
+            </a:r>
+            <a:r>
+              <a:rPr lang="en-US" sz="950" dirty="0">
+                <a:solidFill>
+                  <a:srgbClr val="374151"/>
+                </a:solidFill>
+                <a:latin typeface="Calibri" pitchFamily="34" charset="0"/>
+              </a:rPr>
+              <a:t> — whether the URL contains @, which attackers can use to disguise the real destination.</a:t>
+            </a:r>
+          </a:p>
+        </p:txBody>
+      </p:sp>
+      <p:sp>
+        <p:nvSpPr>
+          <p:cNvPr id="17" name="Text has_query"/>
+          <p:cNvSpPr/>
+          <p:nvPr/>
+        </p:nvSpPr>
+        <p:spPr>
+          <a:xfrm>
+            <a:off x="438912" y="4170000"/>
+            <a:ext cx="4389120" cy="390000"/>
+          </a:xfrm>
+          <a:prstGeom prst="rect">
+            <a:avLst/>
+          </a:prstGeom>
+          <a:noFill/>
+          <a:ln/>
+        </p:spPr>
+        <p:txBody>
+          <a:bodyPr wrap="square" lIns="0" tIns="0" rIns="0" bIns="0" rtlCol="0" anchor="t"/>
+          <a:lstStyle/>
+          <a:p>
+            <a:pPr marL="0" indent="0">
+              <a:buNone/>
+            </a:pPr>
+            <a:r>
+              <a:rPr lang="en-US" sz="950" b="1" dirty="0">
+                <a:solidFill>
+                  <a:srgbClr val="F59E0B"/>
+                </a:solidFill>
+                <a:latin typeface="Calibri" pitchFamily="34" charset="0"/>
+              </a:rPr>
+              <a:t>has_query</a:t>
+            </a:r>
+            <a:r>
+              <a:rPr lang="en-US" sz="950" dirty="0">
+                <a:solidFill>
+                  <a:srgbClr val="374151"/>
+                </a:solidFill>
+                <a:latin typeface="Calibri" pitchFamily="34" charset="0"/>
+              </a:rPr>
+              <a:t> — whether the URL contains a query string, meaning a ? followed by parameters.</a:t>
+            </a:r>
+          </a:p>
+        </p:txBody>
+      </p:sp>
+      <p:sp>
+        <p:nvSpPr>
+          <p:cNvPr id="18" name="Shape PI Bar"/>
+          <p:cNvSpPr/>
+          <p:nvPr/>
+        </p:nvSpPr>
+        <p:spPr>
+          <a:xfrm>
+            <a:off x="5074920" y="730000"/>
+            <a:ext cx="54864" cy="1590000"/>
+          </a:xfrm>
+          <a:prstGeom prst="rect">
+            <a:avLst/>
+          </a:prstGeom>
+          <a:solidFill>
+            <a:srgbClr val="22C55E"/>
+          </a:solidFill>
+          <a:ln w="12700">
+            <a:solidFill>
+              <a:srgbClr val="22C55E"/>
+            </a:solidFill>
+            <a:prstDash val="solid"/>
+          </a:ln>
+        </p:spPr>
+        <p:txBody>
+          <a:bodyPr/>
+          <a:lstStyle/>
+          <a:p>
+            <a:endParaRPr lang="en-IN"/>
+          </a:p>
+        </p:txBody>
+      </p:sp>
+      <p:sp>
+        <p:nvSpPr>
+          <p:cNvPr id="19" name="Text PI Header"/>
+          <p:cNvSpPr/>
+          <p:nvPr/>
+        </p:nvSpPr>
+        <p:spPr>
+          <a:xfrm>
+            <a:off x="5212080" y="730000"/>
+            <a:ext cx="3538728" cy="240000"/>
+          </a:xfrm>
+          <a:prstGeom prst="rect">
+            <a:avLst/>
+          </a:prstGeom>
+          <a:noFill/>
+          <a:ln/>
+        </p:spPr>
+        <p:txBody>
+          <a:bodyPr wrap="square" lIns="0" tIns="0" rIns="0" bIns="0" rtlCol="0" anchor="ctr"/>
+          <a:lstStyle/>
+          <a:p>
+            <a:pPr marL="0" indent="0">
+              <a:buNone/>
+            </a:pPr>
+            <a:r>
+              <a:rPr lang="en-US" sz="1050" b="1" dirty="0">
+                <a:solidFill>
+                  <a:srgbClr val="0D1B2A"/>
+                </a:solidFill>
+                <a:latin typeface="Calibri" pitchFamily="34" charset="0"/>
+                <a:ea typeface="Calibri" pitchFamily="34" charset="-122"/>
+                <a:cs typeface="Calibri" pitchFamily="34" charset="-120"/>
+              </a:rPr>
+              <a:t>Presence Indicators</a:t>
+            </a:r>
+          </a:p>
+        </p:txBody>
+      </p:sp>
+      <p:sp>
+        <p:nvSpPr>
+          <p:cNvPr id="20" name="Text has_scheme"/>
+          <p:cNvSpPr/>
+          <p:nvPr/>
+        </p:nvSpPr>
+        <p:spPr>
+          <a:xfrm>
+            <a:off x="5212080" y="990000"/>
+            <a:ext cx="3538728" cy="390000"/>
+          </a:xfrm>
+          <a:prstGeom prst="rect">
+            <a:avLst/>
+          </a:prstGeom>
+          <a:noFill/>
+          <a:ln/>
+        </p:spPr>
+        <p:txBody>
+          <a:bodyPr wrap="square" lIns="0" tIns="0" rIns="0" bIns="0" rtlCol="0" anchor="t"/>
+          <a:lstStyle/>
+          <a:p>
+            <a:pPr marL="0" indent="0">
+              <a:buNone/>
+            </a:pPr>
+            <a:r>
+              <a:rPr lang="en-US" sz="950" b="1" dirty="0">
+                <a:solidFill>
+                  <a:srgbClr val="22C55E"/>
+                </a:solidFill>
+                <a:latin typeface="Calibri" pitchFamily="34" charset="0"/>
+              </a:rPr>
+              <a:t>has_scheme</a:t>
+            </a:r>
+            <a:r>
+              <a:rPr lang="en-US" sz="950" dirty="0">
+                <a:solidFill>
+                  <a:srgbClr val="374151"/>
+                </a:solidFill>
+                <a:latin typeface="Calibri" pitchFamily="34" charset="0"/>
+              </a:rPr>
+              <a:t> — whether the URL includes a scheme like http:// or https://.</a:t>
+            </a:r>
+          </a:p>
+        </p:txBody>
+      </p:sp>
+      <p:sp>
+        <p:nvSpPr>
+          <p:cNvPr id="21" name="Text has_ip_host"/>
+          <p:cNvSpPr/>
+          <p:nvPr/>
+        </p:nvSpPr>
+        <p:spPr>
+          <a:xfrm>
+            <a:off x="5212080" y="1390000"/>
+            <a:ext cx="3538728" cy="390000"/>
+          </a:xfrm>
+          <a:prstGeom prst="rect">
+            <a:avLst/>
+          </a:prstGeom>
+          <a:noFill/>
+          <a:ln/>
+        </p:spPr>
+        <p:txBody>
+          <a:bodyPr wrap="square" lIns="0" tIns="0" rIns="0" bIns="0" rtlCol="0" anchor="t"/>
+          <a:lstStyle/>
+          <a:p>
+            <a:pPr marL="0" indent="0">
+              <a:buNone/>
+            </a:pPr>
+            <a:r>
+              <a:rPr lang="en-US" sz="950" b="1" dirty="0">
+                <a:solidFill>
+                  <a:srgbClr val="22C55E"/>
+                </a:solidFill>
+                <a:latin typeface="Calibri" pitchFamily="34" charset="0"/>
+              </a:rPr>
+              <a:t>has_ip_host</a:t>
+            </a:r>
+            <a:r>
+              <a:rPr lang="en-US" sz="950" dirty="0">
+                <a:solidFill>
+                  <a:srgbClr val="374151"/>
+                </a:solidFill>
+                <a:latin typeface="Calibri" pitchFamily="34" charset="0"/>
+              </a:rPr>
+              <a:t> — host is a raw IP address (e.g. 192.168.1.1) rather than a normal domain name.</a:t>
+            </a:r>
+          </a:p>
+        </p:txBody>
+      </p:sp>
+      <p:sp>
+        <p:nvSpPr>
+          <p:cNvPr id="22" name="Text has_percent_encoding"/>
+          <p:cNvSpPr/>
+          <p:nvPr/>
+        </p:nvSpPr>
+        <p:spPr>
+          <a:xfrm>
+            <a:off x="5212080" y="1790000"/>
+            <a:ext cx="3538728" cy="430000"/>
+          </a:xfrm>
+          <a:prstGeom prst="rect">
+            <a:avLst/>
+          </a:prstGeom>
+          <a:noFill/>
+          <a:ln/>
+        </p:spPr>
+        <p:txBody>
+          <a:bodyPr wrap="square" lIns="0" tIns="0" rIns="0" bIns="0" rtlCol="0" anchor="t"/>
+          <a:lstStyle/>
+          <a:p>
+            <a:pPr marL="0" indent="0">
+              <a:buNone/>
+            </a:pPr>
+            <a:r>
+              <a:rPr lang="en-US" sz="950" b="1" dirty="0">
+                <a:solidFill>
+                  <a:srgbClr val="22C55E"/>
+                </a:solidFill>
+                <a:latin typeface="Calibri" pitchFamily="34" charset="0"/>
+              </a:rPr>
+              <a:t>has_percent_encoding</a:t>
+            </a:r>
+            <a:r>
+              <a:rPr lang="en-US" sz="950" dirty="0">
+                <a:solidFill>
+                  <a:srgbClr val="374151"/>
+                </a:solidFill>
+                <a:latin typeface="Calibri" pitchFamily="34" charset="0"/>
+              </a:rPr>
+              <a:t> — URL contains encoded characters like %20 for space or %2F for slash.</a:t>
+            </a:r>
+          </a:p>
+        </p:txBody>
+      </p:sp>
+      <p:sp>
+        <p:nvSpPr>
+          <p:cNvPr id="23" name="Shape ST Bar"/>
+          <p:cNvSpPr/>
+          <p:nvPr/>
+        </p:nvSpPr>
+        <p:spPr>
+          <a:xfrm>
+            <a:off x="5074920" y="2460000"/>
+            <a:ext cx="54864" cy="1880000"/>
+          </a:xfrm>
+          <a:prstGeom prst="rect">
+            <a:avLst/>
+          </a:prstGeom>
+          <a:solidFill>
+            <a:srgbClr val="E63946"/>
+          </a:solidFill>
+          <a:ln w="12700">
+            <a:solidFill>
+              <a:srgbClr val="E63946"/>
+            </a:solidFill>
+            <a:prstDash val="solid"/>
+          </a:ln>
+        </p:spPr>
+        <p:txBody>
+          <a:bodyPr/>
+          <a:lstStyle/>
+          <a:p>
+            <a:endParaRPr lang="en-IN"/>
+          </a:p>
+        </p:txBody>
+      </p:sp>
+      <p:sp>
+        <p:nvSpPr>
+          <p:cNvPr id="24" name="Text ST Header"/>
+          <p:cNvSpPr/>
+          <p:nvPr/>
+        </p:nvSpPr>
+        <p:spPr>
+          <a:xfrm>
+            <a:off x="5212080" y="2460000"/>
+            <a:ext cx="3538728" cy="240000"/>
+          </a:xfrm>
+          <a:prstGeom prst="rect">
+            <a:avLst/>
+          </a:prstGeom>
+          <a:noFill/>
+          <a:ln/>
+        </p:spPr>
+        <p:txBody>
+          <a:bodyPr wrap="square" lIns="0" tIns="0" rIns="0" bIns="0" rtlCol="0" anchor="ctr"/>
+          <a:lstStyle/>
+          <a:p>
+            <a:pPr marL="0" indent="0">
+              <a:buNone/>
+            </a:pPr>
+            <a:r>
+              <a:rPr lang="en-US" sz="1050" b="1" dirty="0">
+                <a:solidFill>
+                  <a:srgbClr val="0D1B2A"/>
+                </a:solidFill>
+                <a:latin typeface="Calibri" pitchFamily="34" charset="0"/>
+                <a:ea typeface="Calibri" pitchFamily="34" charset="-122"/>
+                <a:cs typeface="Calibri" pitchFamily="34" charset="-120"/>
+              </a:rPr>
+              <a:t>Suspicious Tokens</a:t>
+            </a:r>
+          </a:p>
+        </p:txBody>
+      </p:sp>
+      <p:sp>
+        <p:nvSpPr>
+          <p:cNvPr id="25" name="Text token_verify"/>
+          <p:cNvSpPr/>
+          <p:nvPr/>
+        </p:nvSpPr>
+        <p:spPr>
+          <a:xfrm>
+            <a:off x="5212080" y="2720000"/>
+            <a:ext cx="3538728" cy="390000"/>
+          </a:xfrm>
+          <a:prstGeom prst="rect">
+            <a:avLst/>
+          </a:prstGeom>
+          <a:noFill/>
+          <a:ln/>
+        </p:spPr>
+        <p:txBody>
+          <a:bodyPr wrap="square" lIns="0" tIns="0" rIns="0" bIns="0" rtlCol="0" anchor="t"/>
+          <a:lstStyle/>
+          <a:p>
+            <a:pPr marL="0" indent="0">
+              <a:buNone/>
+            </a:pPr>
+            <a:r>
+              <a:rPr lang="en-US" sz="950" b="1" dirty="0">
+                <a:solidFill>
+                  <a:srgbClr val="E63946"/>
+                </a:solidFill>
+                <a:latin typeface="Calibri" pitchFamily="34" charset="0"/>
+              </a:rPr>
+              <a:t>token_verify</a:t>
+            </a:r>
+            <a:r>
+              <a:rPr lang="en-US" sz="950" dirty="0">
+                <a:solidFill>
+                  <a:srgbClr val="374151"/>
+                </a:solidFill>
+                <a:latin typeface="Calibri" pitchFamily="34" charset="0"/>
+              </a:rPr>
+              <a:t> — whether verify appears in the URL, common in phishing links to appear legitimate.</a:t>
+            </a:r>
+          </a:p>
+        </p:txBody>
+      </p:sp>
+      <p:sp>
+        <p:nvSpPr>
+          <p:cNvPr id="26" name="Text token_login"/>
+          <p:cNvSpPr/>
+          <p:nvPr/>
+        </p:nvSpPr>
+        <p:spPr>
+          <a:xfrm>
+            <a:off x="5212080" y="3120000"/>
+            <a:ext cx="3538728" cy="390000"/>
+          </a:xfrm>
+          <a:prstGeom prst="rect">
+            <a:avLst/>
+          </a:prstGeom>
+          <a:noFill/>
+          <a:ln/>
+        </p:spPr>
+        <p:txBody>
+          <a:bodyPr wrap="square" lIns="0" tIns="0" rIns="0" bIns="0" rtlCol="0" anchor="t"/>
+          <a:lstStyle/>
+          <a:p>
+            <a:pPr marL="0" indent="0">
+              <a:buNone/>
+            </a:pPr>
+            <a:r>
+              <a:rPr lang="en-US" sz="950" b="1" dirty="0">
+                <a:solidFill>
+                  <a:srgbClr val="E63946"/>
+                </a:solidFill>
+                <a:latin typeface="Calibri" pitchFamily="34" charset="0"/>
+              </a:rPr>
+              <a:t>token_login</a:t>
+            </a:r>
+            <a:r>
+              <a:rPr lang="en-US" sz="950" dirty="0">
+                <a:solidFill>
+                  <a:srgbClr val="374151"/>
+                </a:solidFill>
+                <a:latin typeface="Calibri" pitchFamily="34" charset="0"/>
+              </a:rPr>
+              <a:t> — whether login appears in the URL; attackers build login-lookalike pages to harvest credentials.</a:t>
+            </a:r>
+          </a:p>
+        </p:txBody>
+      </p:sp>
+      <p:sp>
+        <p:nvSpPr>
+          <p:cNvPr id="27" name="Text token_account"/>
+          <p:cNvSpPr/>
+          <p:nvPr/>
+        </p:nvSpPr>
+        <p:spPr>
+          <a:xfrm>
+            <a:off x="5212080" y="3520000"/>
+            <a:ext cx="3538728" cy="390000"/>
+          </a:xfrm>
+          <a:prstGeom prst="rect">
+            <a:avLst/>
+          </a:prstGeom>
+          <a:noFill/>
+          <a:ln/>
+        </p:spPr>
+        <p:txBody>
+          <a:bodyPr wrap="square" lIns="0" tIns="0" rIns="0" bIns="0" rtlCol="0" anchor="t"/>
+          <a:lstStyle/>
+          <a:p>
+            <a:pPr marL="0" indent="0">
+              <a:buNone/>
+            </a:pPr>
+            <a:r>
+              <a:rPr lang="en-US" sz="950" b="1" dirty="0">
+                <a:solidFill>
+                  <a:srgbClr val="E63946"/>
+                </a:solidFill>
+                <a:latin typeface="Calibri" pitchFamily="34" charset="0"/>
+              </a:rPr>
+              <a:t>token_account</a:t>
+            </a:r>
+            <a:r>
+              <a:rPr lang="en-US" sz="950" dirty="0">
+                <a:solidFill>
+                  <a:srgbClr val="374151"/>
+                </a:solidFill>
+                <a:latin typeface="Calibri" pitchFamily="34" charset="0"/>
+              </a:rPr>
+              <a:t> — whether account appears in the URL, used in credential-harvesting phishing links.</a:t>
+            </a:r>
+          </a:p>
+        </p:txBody>
+      </p:sp>
+      <p:sp>
+        <p:nvSpPr>
+          <p:cNvPr id="28" name="Text token_secure"/>
+          <p:cNvSpPr/>
+          <p:nvPr/>
+        </p:nvSpPr>
+        <p:spPr>
+          <a:xfrm>
+            <a:off x="5212080" y="3920000"/>
+            <a:ext cx="3538728" cy="390000"/>
+          </a:xfrm>
+          <a:prstGeom prst="rect">
+            <a:avLst/>
+          </a:prstGeom>
+          <a:noFill/>
+          <a:ln/>
+        </p:spPr>
+        <p:txBody>
+          <a:bodyPr wrap="square" lIns="0" tIns="0" rIns="0" bIns="0" rtlCol="0" anchor="t"/>
+          <a:lstStyle/>
+          <a:p>
+            <a:pPr marL="0" indent="0">
+              <a:buNone/>
+            </a:pPr>
+            <a:r>
+              <a:rPr lang="en-US" sz="950" b="1" dirty="0">
+                <a:solidFill>
+                  <a:srgbClr val="E63946"/>
+                </a:solidFill>
+                <a:latin typeface="Calibri" pitchFamily="34" charset="0"/>
+              </a:rPr>
+              <a:t>token_secure</a:t>
+            </a:r>
+            <a:r>
+              <a:rPr lang="en-US" sz="950" dirty="0">
+                <a:solidFill>
+                  <a:srgbClr val="374151"/>
+                </a:solidFill>
+                <a:latin typeface="Calibri" pitchFamily="34" charset="0"/>
+              </a:rPr>
+              <a:t> — whether secure appears in the URL, often used to make a fake link look trustworthy.</a:t>
+            </a:r>
+          </a:p>
+        </p:txBody>
+      </p:sp>
+      <p:sp>
+        <p:nvSpPr>
+          <p:cNvPr id="29" name="Shape Divider"/>
+          <p:cNvSpPr/>
+          <p:nvPr/>
+        </p:nvSpPr>
+        <p:spPr>
+          <a:xfrm>
+            <a:off x="4921920" y="730000"/>
+            <a:ext cx="0" cy="4062040"/>
+          </a:xfrm>
+          <a:prstGeom prst="line">
+            <a:avLst/>
+          </a:prstGeom>
+          <a:noFill/>
+          <a:ln w="9525">
+            <a:solidFill>
+              <a:srgbClr val="D1D5DB"/>
+            </a:solidFill>
+            <a:prstDash val="solid"/>
+          </a:ln>
+        </p:spPr>
+        <p:txBody>
+          <a:bodyPr/>
+          <a:lstStyle/>
+          <a:p>
+            <a:endParaRPr lang="en-IN"/>
+          </a:p>
+        </p:txBody>
+      </p:sp>
+    </p:spTree>
+  </p:cSld>
+  <p:clrMapOvr>
+    <a:masterClrMapping/>
+  </p:clrMapOvr>
+</p:sld>
+</file>
+
+<file path=ppt/slides/slide8.xml><?xml version="1.0" encoding="utf-8"?>
 <p:sld xmlns:a="http://schemas.openxmlformats.org/drawingml/2006/main" xmlns:r="http://schemas.openxmlformats.org/officeDocument/2006/relationships" xmlns:p="http://schemas.openxmlformats.org/presentationml/2006/main">
   <p:cSld name="Slide 13">
     <p:bg>
@@ -24707,7 +26572,7 @@
 </p:sld>
 </file>
 
-<file path=ppt/slides/slide8.xml><?xml version="1.0" encoding="utf-8"?>
+<file path=ppt/slides/slide9.xml><?xml version="1.0" encoding="utf-8"?>
 <p:sld xmlns:a="http://schemas.openxmlformats.org/drawingml/2006/main" xmlns:r="http://schemas.openxmlformats.org/officeDocument/2006/relationships" xmlns:p="http://schemas.openxmlformats.org/presentationml/2006/main">
   <p:cSld name="Slide 14">
     <p:bg>
@@ -25321,608 +27186,6 @@
                 <a:latin typeface="Calibri" pitchFamily="34" charset="0"/>
               </a:rPr>
               <a:t>Logistic Regression = interpretable — shows which features matter</a:t>
-            </a:r>
-          </a:p>
-        </p:txBody>
-      </p:sp>
-    </p:spTree>
-  </p:cSld>
-  <p:clrMapOvr>
-    <a:masterClrMapping/>
-  </p:clrMapOvr>
-</p:sld>
-</file>
-
-<file path=ppt/slides/slide9.xml><?xml version="1.0" encoding="utf-8"?>
-<p:sld xmlns:a="http://schemas.openxmlformats.org/drawingml/2006/main" xmlns:r="http://schemas.openxmlformats.org/officeDocument/2006/relationships" xmlns:p="http://schemas.openxmlformats.org/presentationml/2006/main">
-  <p:cSld name="Slide 15">
-    <p:bg>
-      <p:bgPr>
-        <a:solidFill>
-          <a:srgbClr val="F4F7FA"/>
-        </a:solidFill>
-        <a:effectLst/>
-      </p:bgPr>
-    </p:bg>
-    <p:spTree>
-      <p:nvGrpSpPr>
-        <p:cNvPr id="1" name=""/>
-        <p:cNvGrpSpPr/>
-        <p:nvPr/>
-      </p:nvGrpSpPr>
-      <p:grpSpPr>
-        <a:xfrm>
-          <a:off x="0" y="0"/>
-          <a:ext cx="0" cy="0"/>
-          <a:chOff x="0" y="0"/>
-          <a:chExt cx="0" cy="0"/>
-        </a:xfrm>
-      </p:grpSpPr>
-      <p:sp>
-        <p:nvSpPr>
-          <p:cNvPr id="2" name="Hdr"/>
-          <p:cNvSpPr/>
-          <p:nvPr/>
-        </p:nvSpPr>
-        <p:spPr>
-          <a:xfrm>
-            <a:off x="0" y="0"/>
-            <a:ext cx="9144000" cy="658368"/>
-          </a:xfrm>
-          <a:prstGeom prst="rect">
-            <a:avLst/>
-          </a:prstGeom>
-          <a:solidFill>
-            <a:srgbClr val="0D1B2A"/>
-          </a:solidFill>
-          <a:ln w="12700">
-            <a:solidFill>
-              <a:srgbClr val="0D1B2A"/>
-            </a:solidFill>
-            <a:prstDash val="solid"/>
-          </a:ln>
-        </p:spPr>
-        <p:txBody>
-          <a:bodyPr/>
-          <a:lstStyle/>
-          <a:p>
-            <a:endParaRPr lang="en-US"/>
-          </a:p>
-        </p:txBody>
-      </p:sp>
-      <p:sp>
-        <p:nvSpPr>
-          <p:cNvPr id="3" name="HdrTxt"/>
-          <p:cNvSpPr/>
-          <p:nvPr/>
-        </p:nvSpPr>
-        <p:spPr>
-          <a:xfrm>
-            <a:off x="384048" y="0"/>
-            <a:ext cx="8412480" cy="658368"/>
-          </a:xfrm>
-          <a:prstGeom prst="rect">
-            <a:avLst/>
-          </a:prstGeom>
-          <a:noFill/>
-          <a:ln/>
-        </p:spPr>
-        <p:txBody>
-          <a:bodyPr wrap="square" lIns="0" tIns="0" rIns="0" bIns="0" rtlCol="0" anchor="ctr"/>
-          <a:lstStyle/>
-          <a:p>
-            <a:pPr marL="0" indent="0">
-              <a:buNone/>
-            </a:pPr>
-            <a:r>
-              <a:rPr lang="en-US" sz="2000" b="1" dirty="0">
-                <a:solidFill>
-                  <a:srgbClr val="FFFFFF"/>
-                </a:solidFill>
-                <a:latin typeface="Calibri" pitchFamily="34" charset="0"/>
-              </a:rPr>
-              <a:t>Model: Logistic Regression</a:t>
-            </a:r>
-          </a:p>
-        </p:txBody>
-      </p:sp>
-      <p:sp>
-        <p:nvSpPr>
-          <p:cNvPr id="4" name="Ftr"/>
-          <p:cNvSpPr/>
-          <p:nvPr/>
-        </p:nvSpPr>
-        <p:spPr>
-          <a:xfrm>
-            <a:off x="0" y="4892040"/>
-            <a:ext cx="9144000" cy="251460"/>
-          </a:xfrm>
-          <a:prstGeom prst="rect">
-            <a:avLst/>
-          </a:prstGeom>
-          <a:solidFill>
-            <a:srgbClr val="1B2A41"/>
-          </a:solidFill>
-          <a:ln w="12700">
-            <a:solidFill>
-              <a:srgbClr val="1B2A41"/>
-            </a:solidFill>
-            <a:prstDash val="solid"/>
-          </a:ln>
-        </p:spPr>
-        <p:txBody>
-          <a:bodyPr/>
-          <a:lstStyle/>
-          <a:p>
-            <a:endParaRPr lang="en-US"/>
-          </a:p>
-        </p:txBody>
-      </p:sp>
-      <p:sp>
-        <p:nvSpPr>
-          <p:cNvPr id="5" name="FtrTxt"/>
-          <p:cNvSpPr/>
-          <p:nvPr/>
-        </p:nvSpPr>
-        <p:spPr>
-          <a:xfrm>
-            <a:off x="274320" y="4892040"/>
-            <a:ext cx="8595360" cy="251460"/>
-          </a:xfrm>
-          <a:prstGeom prst="rect">
-            <a:avLst/>
-          </a:prstGeom>
-          <a:noFill/>
-          <a:ln/>
-        </p:spPr>
-        <p:txBody>
-          <a:bodyPr wrap="square" lIns="0" tIns="0" rIns="0" bIns="0" rtlCol="0" anchor="ctr"/>
-          <a:lstStyle/>
-          <a:p>
-            <a:pPr marL="0" indent="0">
-              <a:buNone/>
-            </a:pPr>
-            <a:r>
-              <a:rPr lang="en-US" sz="800" dirty="0">
-                <a:solidFill>
-                  <a:srgbClr val="CADCFC"/>
-                </a:solidFill>
-                <a:latin typeface="Calibri" pitchFamily="34" charset="0"/>
-              </a:rPr>
-              <a:t>Malicious URL Detection  ·  Lexical Features Only  |  Model Concepts</a:t>
-            </a:r>
-          </a:p>
-        </p:txBody>
-      </p:sp>
-      <p:sp>
-        <p:nvSpPr>
-          <p:cNvPr id="6" name="LH"/>
-          <p:cNvSpPr/>
-          <p:nvPr/>
-        </p:nvSpPr>
-        <p:spPr>
-          <a:xfrm>
-            <a:off x="320040" y="750000"/>
-            <a:ext cx="4114800" cy="292608"/>
-          </a:xfrm>
-          <a:prstGeom prst="rect">
-            <a:avLst/>
-          </a:prstGeom>
-          <a:noFill/>
-          <a:ln/>
-        </p:spPr>
-        <p:txBody>
-          <a:bodyPr wrap="square" lIns="0" tIns="0" rIns="0" bIns="0" rtlCol="0" anchor="ctr"/>
-          <a:lstStyle/>
-          <a:p>
-            <a:pPr marL="0" indent="0">
-              <a:buNone/>
-            </a:pPr>
-            <a:r>
-              <a:rPr lang="en-US" sz="1300" b="1" dirty="0">
-                <a:solidFill>
-                  <a:srgbClr val="0D1B2A"/>
-                </a:solidFill>
-                <a:latin typeface="Calibri" pitchFamily="34" charset="0"/>
-              </a:rPr>
-              <a:t>How Logistic Regression Works</a:t>
-            </a:r>
-          </a:p>
-        </p:txBody>
-      </p:sp>
-      <p:sp>
-        <p:nvSpPr>
-          <p:cNvPr id="7" name="LB"/>
-          <p:cNvSpPr/>
-          <p:nvPr/>
-        </p:nvSpPr>
-        <p:spPr>
-          <a:xfrm>
-            <a:off x="320040" y="1080000"/>
-            <a:ext cx="4114800" cy="1480000"/>
-          </a:xfrm>
-          <a:prstGeom prst="rect">
-            <a:avLst/>
-          </a:prstGeom>
-          <a:noFill/>
-          <a:ln/>
-        </p:spPr>
-        <p:txBody>
-          <a:bodyPr wrap="square" lIns="0" tIns="0" rIns="0" bIns="0" rtlCol="0" anchor="t"/>
-          <a:lstStyle/>
-          <a:p>
-            <a:pPr marL="342900" indent="-342900">
-              <a:buSzPct val="100000"/>
-              <a:buChar char="•"/>
-            </a:pPr>
-            <a:r>
-              <a:rPr lang="en-US" sz="1050" dirty="0">
-                <a:solidFill>
-                  <a:srgbClr val="334155"/>
-                </a:solidFill>
-                <a:latin typeface="Calibri" pitchFamily="34" charset="0"/>
-              </a:rPr>
-              <a:t>Fits a weighted formula to the features and outputs a </a:t>
-            </a:r>
-            <a:r>
-              <a:rPr lang="en-US" sz="1050" b="1" dirty="0">
-                <a:solidFill>
-                  <a:srgbClr val="334155"/>
-                </a:solidFill>
-                <a:latin typeface="Calibri" pitchFamily="34" charset="0"/>
-              </a:rPr>
-              <a:t>probability of each class</a:t>
-            </a:r>
-          </a:p>
-          <a:p>
-            <a:pPr marL="342900" indent="-342900">
-              <a:buSzPct val="100000"/>
-              <a:buChar char="•"/>
-            </a:pPr>
-            <a:r>
-              <a:rPr lang="en-US" sz="1050" dirty="0">
-                <a:solidFill>
-                  <a:srgbClr val="334155"/>
-                </a:solidFill>
-                <a:latin typeface="Calibri" pitchFamily="34" charset="0"/>
-              </a:rPr>
-              <a:t>Each feature gets a </a:t>
-            </a:r>
-            <a:r>
-              <a:rPr lang="en-US" sz="1050" b="1" dirty="0">
-                <a:solidFill>
-                  <a:srgbClr val="334155"/>
-                </a:solidFill>
-                <a:latin typeface="Calibri" pitchFamily="34" charset="0"/>
-              </a:rPr>
-              <a:t>coefficient</a:t>
-            </a:r>
-            <a:r>
-              <a:rPr lang="en-US" sz="1050" dirty="0">
-                <a:solidFill>
-                  <a:srgbClr val="334155"/>
-                </a:solidFill>
-                <a:latin typeface="Calibri" pitchFamily="34" charset="0"/>
-              </a:rPr>
-              <a:t> — a positive value pushes toward malicious, negative toward benign</a:t>
-            </a:r>
-          </a:p>
-          <a:p>
-            <a:pPr marL="342900" indent="-342900">
-              <a:buSzPct val="100000"/>
-              <a:buChar char="•"/>
-            </a:pPr>
-            <a:r>
-              <a:rPr lang="en-US" sz="1050" dirty="0">
-                <a:solidFill>
-                  <a:srgbClr val="334155"/>
-                </a:solidFill>
-                <a:latin typeface="Calibri" pitchFamily="34" charset="0"/>
-              </a:rPr>
-              <a:t>Interpretable: you can read the coefficients to understand which URL features matter most</a:t>
-            </a:r>
-          </a:p>
-        </p:txBody>
-      </p:sp>
-      <p:sp>
-        <p:nvSpPr>
-          <p:cNvPr id="8" name="LSettings"/>
-          <p:cNvSpPr/>
-          <p:nvPr/>
-        </p:nvSpPr>
-        <p:spPr>
-          <a:xfrm>
-            <a:off x="320040" y="2680000"/>
-            <a:ext cx="4114800" cy="1080000"/>
-          </a:xfrm>
-          <a:prstGeom prst="rect">
-            <a:avLst/>
-          </a:prstGeom>
-          <a:solidFill>
-            <a:srgbClr val="E8F4F8"/>
-          </a:solidFill>
-          <a:ln w="9525">
-            <a:solidFill>
-              <a:srgbClr val="028090"/>
-            </a:solidFill>
-            <a:prstDash val="solid"/>
-          </a:ln>
-          <a:effectLst>
-            <a:outerShdw blurRad="101600" dist="38100" dir="8100000" algn="bl" rotWithShape="0">
-              <a:srgbClr val="000000">
-                <a:alpha val="12000"/>
-              </a:srgbClr>
-            </a:outerShdw>
-          </a:effectLst>
-        </p:spPr>
-        <p:txBody>
-          <a:bodyPr wrap="square" lIns="91440" tIns="91440" rIns="91440" bIns="91440" rtlCol="0" anchor="t"/>
-          <a:lstStyle/>
-          <a:p>
-            <a:pPr marL="0" indent="0">
-              <a:buNone/>
-            </a:pPr>
-            <a:r>
-              <a:rPr lang="en-US" sz="1100" b="1" dirty="0">
-                <a:solidFill>
-                  <a:srgbClr val="028090"/>
-                </a:solidFill>
-                <a:latin typeface="Calibri" pitchFamily="34" charset="0"/>
-              </a:rPr>
-              <a:t>Settings used: C=10, class_weight=balanced</a:t>
-            </a:r>
-          </a:p>
-          <a:p>
-            <a:pPr marL="342900" indent="-342900">
-              <a:buSzPct val="100000"/>
-              <a:buChar char="•"/>
-            </a:pPr>
-            <a:r>
-              <a:rPr lang="en-US" sz="1000" dirty="0">
-                <a:solidFill>
-                  <a:srgbClr val="334155"/>
-                </a:solidFill>
-                <a:latin typeface="Calibri" pitchFamily="34" charset="0"/>
-              </a:rPr>
-              <a:t>C=10: weak regularisation, allows the model to fit the data closely</a:t>
-            </a:r>
-          </a:p>
-          <a:p>
-            <a:pPr marL="342900" indent="-342900">
-              <a:buSzPct val="100000"/>
-              <a:buChar char="•"/>
-            </a:pPr>
-            <a:r>
-              <a:rPr lang="en-US" sz="1000" dirty="0">
-                <a:solidFill>
-                  <a:srgbClr val="334155"/>
-                </a:solidFill>
-                <a:latin typeface="Calibri" pitchFamily="34" charset="0"/>
-              </a:rPr>
-              <a:t>balanced weights: minority classes (malware, phishing) are up-weighted so the model does not ignore them</a:t>
-            </a:r>
-          </a:p>
-        </p:txBody>
-      </p:sp>
-      <p:sp>
-        <p:nvSpPr>
-          <p:cNvPr id="9" name="Div"/>
-          <p:cNvSpPr/>
-          <p:nvPr/>
-        </p:nvSpPr>
-        <p:spPr>
-          <a:xfrm>
-            <a:off x="4572000" y="720000"/>
-            <a:ext cx="27432" cy="4072000"/>
-          </a:xfrm>
-          <a:prstGeom prst="rect">
-            <a:avLst/>
-          </a:prstGeom>
-          <a:solidFill>
-            <a:srgbClr val="CADCFC"/>
-          </a:solidFill>
-          <a:ln w="0">
-            <a:noFill/>
-          </a:ln>
-        </p:spPr>
-        <p:txBody>
-          <a:bodyPr/>
-          <a:lstStyle/>
-          <a:p>
-            <a:endParaRPr lang="en-US"/>
-          </a:p>
-        </p:txBody>
-      </p:sp>
-      <p:sp>
-        <p:nvSpPr>
-          <p:cNvPr id="10" name="RH"/>
-          <p:cNvSpPr/>
-          <p:nvPr/>
-        </p:nvSpPr>
-        <p:spPr>
-          <a:xfrm>
-            <a:off x="4709160" y="750000"/>
-            <a:ext cx="4160880" cy="292608"/>
-          </a:xfrm>
-          <a:prstGeom prst="rect">
-            <a:avLst/>
-          </a:prstGeom>
-          <a:noFill/>
-          <a:ln/>
-        </p:spPr>
-        <p:txBody>
-          <a:bodyPr wrap="square" lIns="0" tIns="0" rIns="0" bIns="0" rtlCol="0" anchor="ctr"/>
-          <a:lstStyle/>
-          <a:p>
-            <a:pPr marL="0" indent="0">
-              <a:buNone/>
-            </a:pPr>
-            <a:r>
-              <a:rPr lang="en-US" sz="1300" b="1" dirty="0">
-                <a:solidFill>
-                  <a:srgbClr val="0D1B2A"/>
-                </a:solidFill>
-                <a:latin typeface="Calibri" pitchFamily="34" charset="0"/>
-              </a:rPr>
-              <a:t>Why LR Suits This Problem</a:t>
-            </a:r>
-          </a:p>
-        </p:txBody>
-      </p:sp>
-      <p:sp>
-        <p:nvSpPr>
-          <p:cNvPr id="11" name="RB"/>
-          <p:cNvSpPr/>
-          <p:nvPr/>
-        </p:nvSpPr>
-        <p:spPr>
-          <a:xfrm>
-            <a:off x="4709160" y="1080000"/>
-            <a:ext cx="4160880" cy="1440000"/>
-          </a:xfrm>
-          <a:prstGeom prst="rect">
-            <a:avLst/>
-          </a:prstGeom>
-          <a:noFill/>
-          <a:ln/>
-        </p:spPr>
-        <p:txBody>
-          <a:bodyPr wrap="square" lIns="0" tIns="0" rIns="0" bIns="0" rtlCol="0" anchor="t"/>
-          <a:lstStyle/>
-          <a:p>
-            <a:pPr marL="342900" indent="-342900">
-              <a:buSzPct val="100000"/>
-              <a:buChar char="•"/>
-            </a:pPr>
-            <a:r>
-              <a:rPr lang="en-US" sz="1050" dirty="0">
-                <a:solidFill>
-                  <a:srgbClr val="334155"/>
-                </a:solidFill>
-                <a:latin typeface="Calibri" pitchFamily="34" charset="0"/>
-              </a:rPr>
-              <a:t>Coefficients reveal which URL features most distinguish malicious from benign — directly answering the project question</a:t>
-            </a:r>
-          </a:p>
-          <a:p>
-            <a:pPr marL="342900" indent="-342900">
-              <a:buSzPct val="100000"/>
-              <a:buChar char="•"/>
-            </a:pPr>
-            <a:r>
-              <a:rPr lang="en-US" sz="1050" dirty="0">
-                <a:solidFill>
-                  <a:srgbClr val="334155"/>
-                </a:solidFill>
-                <a:latin typeface="Calibri" pitchFamily="34" charset="0"/>
-              </a:rPr>
-              <a:t>Balanced class weights directly counter the 18:1 imbalance — minority classes are not ignored</a:t>
-            </a:r>
-          </a:p>
-          <a:p>
-            <a:pPr marL="342900" indent="-342900">
-              <a:buSzPct val="100000"/>
-              <a:buChar char="•"/>
-            </a:pPr>
-            <a:r>
-              <a:rPr lang="en-US" sz="1050" dirty="0">
-                <a:solidFill>
-                  <a:srgbClr val="334155"/>
-                </a:solidFill>
-                <a:latin typeface="Calibri" pitchFamily="34" charset="0"/>
-              </a:rPr>
-              <a:t>Fast to train — practical for the 64K-sample training set used here</a:t>
-            </a:r>
-          </a:p>
-        </p:txBody>
-      </p:sp>
-      <p:sp>
-        <p:nvSpPr>
-          <p:cNvPr id="12" name="RoleBox"/>
-          <p:cNvSpPr/>
-          <p:nvPr/>
-        </p:nvSpPr>
-        <p:spPr>
-          <a:xfrm>
-            <a:off x="4709160" y="2620000"/>
-            <a:ext cx="4160880" cy="1060000"/>
-          </a:xfrm>
-          <a:prstGeom prst="rect">
-            <a:avLst/>
-          </a:prstGeom>
-          <a:solidFill>
-            <a:srgbClr val="CADCFC"/>
-          </a:solidFill>
-          <a:ln w="9525">
-            <a:solidFill>
-              <a:srgbClr val="1B2A41"/>
-            </a:solidFill>
-            <a:prstDash val="solid"/>
-          </a:ln>
-        </p:spPr>
-        <p:txBody>
-          <a:bodyPr wrap="square" lIns="91440" tIns="91440" rIns="91440" bIns="91440" rtlCol="0" anchor="t"/>
-          <a:lstStyle/>
-          <a:p>
-            <a:pPr marL="0" indent="0">
-              <a:buNone/>
-            </a:pPr>
-            <a:r>
-              <a:rPr lang="en-US" sz="1050" b="1" dirty="0">
-                <a:solidFill>
-                  <a:srgbClr val="0D1B2A"/>
-                </a:solidFill>
-                <a:latin typeface="Calibri" pitchFamily="34" charset="0"/>
-              </a:rPr>
-              <a:t>Role in this project</a:t>
-            </a:r>
-          </a:p>
-          <a:p>
-            <a:pPr marL="342900" indent="-342900">
-              <a:buSzPct val="100000"/>
-              <a:buChar char="•"/>
-            </a:pPr>
-            <a:r>
-              <a:rPr lang="en-US" sz="1000" dirty="0">
-                <a:solidFill>
-                  <a:srgbClr val="334155"/>
-                </a:solidFill>
-                <a:latin typeface="Calibri" pitchFamily="34" charset="0"/>
-              </a:rPr>
-              <a:t>The </a:t>
-            </a:r>
-            <a:r>
-              <a:rPr lang="en-US" sz="1000" b="1" dirty="0">
-                <a:solidFill>
-                  <a:srgbClr val="334155"/>
-                </a:solidFill>
-                <a:latin typeface="Calibri" pitchFamily="34" charset="0"/>
-              </a:rPr>
-              <a:t>interpretable</a:t>
-            </a:r>
-            <a:r>
-              <a:rPr lang="en-US" sz="1000" dirty="0">
-                <a:solidFill>
-                  <a:srgbClr val="334155"/>
-                </a:solidFill>
-                <a:latin typeface="Calibri" pitchFamily="34" charset="0"/>
-              </a:rPr>
-              <a:t> model — weaker predictor than k-NN but explains which features drive the classification decision</a:t>
-            </a:r>
-          </a:p>
-          <a:p>
-            <a:pPr marL="342900" indent="-342900">
-              <a:buSzPct val="100000"/>
-              <a:buChar char="•"/>
-            </a:pPr>
-            <a:r>
-              <a:rPr lang="en-US" sz="1000" dirty="0">
-                <a:solidFill>
-                  <a:srgbClr val="334155"/>
-                </a:solidFill>
-                <a:latin typeface="Calibri" pitchFamily="34" charset="0"/>
-              </a:rPr>
-              <a:t>Bal Acc 0.843 (binary) — respectable but k-NN scores 0.935</a:t>
             </a:r>
           </a:p>
         </p:txBody>

</xml_diff>

<commit_message>
docs(minor changes in part2 ppt)
</commit_message>
<xml_diff>
--- a/Part2.pptx
+++ b/Part2.pptx
@@ -13337,6 +13337,47 @@
                 <a:cs typeface="Calibri" pitchFamily="34" charset="-120"/>
               </a:rPr>
               <a:t>Real-world detection would need DNS, WHOIS, content analysis, and temporal validation on top of this.</a:t>
+            </a:r>
+            <a:r>
+              <a:rPr lang="en-GB" sz="950" dirty="0">
+                <a:solidFill>
+                  <a:srgbClr val="CADCFC"/>
+                </a:solidFill>
+                <a:latin typeface="Calibri" pitchFamily="34" charset="0"/>
+                <a:ea typeface="Calibri" pitchFamily="34" charset="-122"/>
+                <a:cs typeface="Calibri" pitchFamily="34" charset="-120"/>
+              </a:rPr>
+              <a:t> </a:t>
+            </a:r>
+          </a:p>
+          <a:p>
+            <a:pPr marL="0" indent="0">
+              <a:buNone/>
+            </a:pPr>
+            <a:r>
+              <a:rPr lang="en-GB" sz="900" dirty="0">
+                <a:solidFill>
+                  <a:srgbClr val="CADCFC"/>
+                </a:solidFill>
+                <a:latin typeface="Calibri" pitchFamily="34" charset="0"/>
+                <a:ea typeface="Calibri" pitchFamily="34" charset="-122"/>
+                <a:cs typeface="Calibri" pitchFamily="34" charset="-120"/>
+              </a:rPr>
+              <a:t>Temporal validation means evaluating the model on later data than it was trained on, to check whether it still works as patterns change over time.</a:t>
+            </a:r>
+            <a:endParaRPr lang="en-US" sz="900" dirty="0">
+              <a:solidFill>
+                <a:srgbClr val="CADCFC"/>
+              </a:solidFill>
+              <a:latin typeface="Calibri" pitchFamily="34" charset="0"/>
+              <a:ea typeface="Calibri" pitchFamily="34" charset="-122"/>
+              <a:cs typeface="Calibri" pitchFamily="34" charset="-120"/>
+            </a:endParaRPr>
+          </a:p>
+          <a:p>
+            <a:r>
+              <a:rPr lang="en-GB" sz="1000" dirty="0"/>
+              <a:t>.</a:t>
             </a:r>
             <a:endParaRPr lang="en-US" sz="950" dirty="0"/>
           </a:p>

</xml_diff>